<commit_message>
Update Part 5 Causal Effect Estimation.pptx
</commit_message>
<xml_diff>
--- a/slides/Part 5 Causal Effect Estimation.pptx
+++ b/slides/Part 5 Causal Effect Estimation.pptx
@@ -1,31 +1,131 @@
 
 <file path=ppt/presentation.xml><?xml version="1.0" encoding="utf-8"?>
-<p:presentation xmlns:a="http://schemas.openxmlformats.org/drawingml/2006/main" xmlns:p="http://schemas.openxmlformats.org/presentationml/2006/main" xmlns:r="http://schemas.openxmlformats.org/officeDocument/2006/relationships" xmlns:p14="http://schemas.microsoft.com/office/powerpoint/2010/main" xmlns:p15="http://schemas.microsoft.com/office/powerpoint/2012/main" xmlns:mc="http://schemas.openxmlformats.org/markup-compatibility/2006">
+<p:presentation xmlns:a="http://schemas.openxmlformats.org/drawingml/2006/main" xmlns:r="http://schemas.openxmlformats.org/officeDocument/2006/relationships" xmlns:p="http://schemas.openxmlformats.org/presentationml/2006/main">
   <p:sldMasterIdLst>
-    <p:sldMasterId id="2147483648" r:id="rId2"/>
+    <p:sldMasterId id="2147483648" r:id="rId1"/>
   </p:sldMasterIdLst>
   <p:notesMasterIdLst>
-    <p:notesMasterId r:id="rId3"/>
+    <p:notesMasterId r:id="rId11"/>
   </p:notesMasterIdLst>
   <p:sldIdLst>
-    <p:sldId id="256" r:id="rId4"/>
-    <p:sldId id="257" r:id="rId5"/>
-    <p:sldId id="258" r:id="rId6"/>
-    <p:sldId id="259" r:id="rId7"/>
-    <p:sldId id="260" r:id="rId8"/>
-    <p:sldId id="261" r:id="rId9"/>
-    <p:sldId id="262" r:id="rId10"/>
-    <p:sldId id="263" r:id="rId11"/>
-    <p:sldId id="264" r:id="rId12"/>
+    <p:sldId id="256" r:id="rId2"/>
+    <p:sldId id="257" r:id="rId3"/>
+    <p:sldId id="258" r:id="rId4"/>
+    <p:sldId id="259" r:id="rId5"/>
+    <p:sldId id="260" r:id="rId6"/>
+    <p:sldId id="261" r:id="rId7"/>
+    <p:sldId id="262" r:id="rId8"/>
+    <p:sldId id="263" r:id="rId9"/>
+    <p:sldId id="264" r:id="rId10"/>
   </p:sldIdLst>
-  <p:sldSz cx="9144000" cy="5143500"/>
+  <p:sldSz cx="9144000" cy="5143500" type="screen16x9"/>
   <p:notesSz cx="5143500" cy="9144000"/>
+  <p:defaultTextStyle>
+    <a:defPPr>
+      <a:defRPr lang="en-SE"/>
+    </a:defPPr>
+    <a:lvl1pPr marL="0" algn="l" defTabSz="914400" rtl="0" eaLnBrk="1" latinLnBrk="0" hangingPunct="1">
+      <a:defRPr sz="1800" kern="1200">
+        <a:solidFill>
+          <a:schemeClr val="tx1"/>
+        </a:solidFill>
+        <a:latin typeface="+mn-lt"/>
+        <a:ea typeface="+mn-ea"/>
+        <a:cs typeface="+mn-cs"/>
+      </a:defRPr>
+    </a:lvl1pPr>
+    <a:lvl2pPr marL="457200" algn="l" defTabSz="914400" rtl="0" eaLnBrk="1" latinLnBrk="0" hangingPunct="1">
+      <a:defRPr sz="1800" kern="1200">
+        <a:solidFill>
+          <a:schemeClr val="tx1"/>
+        </a:solidFill>
+        <a:latin typeface="+mn-lt"/>
+        <a:ea typeface="+mn-ea"/>
+        <a:cs typeface="+mn-cs"/>
+      </a:defRPr>
+    </a:lvl2pPr>
+    <a:lvl3pPr marL="914400" algn="l" defTabSz="914400" rtl="0" eaLnBrk="1" latinLnBrk="0" hangingPunct="1">
+      <a:defRPr sz="1800" kern="1200">
+        <a:solidFill>
+          <a:schemeClr val="tx1"/>
+        </a:solidFill>
+        <a:latin typeface="+mn-lt"/>
+        <a:ea typeface="+mn-ea"/>
+        <a:cs typeface="+mn-cs"/>
+      </a:defRPr>
+    </a:lvl3pPr>
+    <a:lvl4pPr marL="1371600" algn="l" defTabSz="914400" rtl="0" eaLnBrk="1" latinLnBrk="0" hangingPunct="1">
+      <a:defRPr sz="1800" kern="1200">
+        <a:solidFill>
+          <a:schemeClr val="tx1"/>
+        </a:solidFill>
+        <a:latin typeface="+mn-lt"/>
+        <a:ea typeface="+mn-ea"/>
+        <a:cs typeface="+mn-cs"/>
+      </a:defRPr>
+    </a:lvl4pPr>
+    <a:lvl5pPr marL="1828800" algn="l" defTabSz="914400" rtl="0" eaLnBrk="1" latinLnBrk="0" hangingPunct="1">
+      <a:defRPr sz="1800" kern="1200">
+        <a:solidFill>
+          <a:schemeClr val="tx1"/>
+        </a:solidFill>
+        <a:latin typeface="+mn-lt"/>
+        <a:ea typeface="+mn-ea"/>
+        <a:cs typeface="+mn-cs"/>
+      </a:defRPr>
+    </a:lvl5pPr>
+    <a:lvl6pPr marL="2286000" algn="l" defTabSz="914400" rtl="0" eaLnBrk="1" latinLnBrk="0" hangingPunct="1">
+      <a:defRPr sz="1800" kern="1200">
+        <a:solidFill>
+          <a:schemeClr val="tx1"/>
+        </a:solidFill>
+        <a:latin typeface="+mn-lt"/>
+        <a:ea typeface="+mn-ea"/>
+        <a:cs typeface="+mn-cs"/>
+      </a:defRPr>
+    </a:lvl6pPr>
+    <a:lvl7pPr marL="2743200" algn="l" defTabSz="914400" rtl="0" eaLnBrk="1" latinLnBrk="0" hangingPunct="1">
+      <a:defRPr sz="1800" kern="1200">
+        <a:solidFill>
+          <a:schemeClr val="tx1"/>
+        </a:solidFill>
+        <a:latin typeface="+mn-lt"/>
+        <a:ea typeface="+mn-ea"/>
+        <a:cs typeface="+mn-cs"/>
+      </a:defRPr>
+    </a:lvl7pPr>
+    <a:lvl8pPr marL="3200400" algn="l" defTabSz="914400" rtl="0" eaLnBrk="1" latinLnBrk="0" hangingPunct="1">
+      <a:defRPr sz="1800" kern="1200">
+        <a:solidFill>
+          <a:schemeClr val="tx1"/>
+        </a:solidFill>
+        <a:latin typeface="+mn-lt"/>
+        <a:ea typeface="+mn-ea"/>
+        <a:cs typeface="+mn-cs"/>
+      </a:defRPr>
+    </a:lvl8pPr>
+    <a:lvl9pPr marL="3657600" algn="l" defTabSz="914400" rtl="0" eaLnBrk="1" latinLnBrk="0" hangingPunct="1">
+      <a:defRPr sz="1800" kern="1200">
+        <a:solidFill>
+          <a:schemeClr val="tx1"/>
+        </a:solidFill>
+        <a:latin typeface="+mn-lt"/>
+        <a:ea typeface="+mn-ea"/>
+        <a:cs typeface="+mn-cs"/>
+      </a:defRPr>
+    </a:lvl9pPr>
+  </p:defaultTextStyle>
 </p:presentation>
 </file>
 
 <file path=ppt/notesMasters/notesMaster1.xml><?xml version="1.0" encoding="utf-8"?>
-<p:notesMaster xmlns:a="http://schemas.openxmlformats.org/drawingml/2006/main" xmlns:p="http://schemas.openxmlformats.org/presentationml/2006/main" xmlns:r="http://schemas.openxmlformats.org/officeDocument/2006/relationships" xmlns:p14="http://schemas.microsoft.com/office/powerpoint/2010/main" xmlns:p15="http://schemas.microsoft.com/office/powerpoint/2012/main" xmlns:mc="http://schemas.openxmlformats.org/markup-compatibility/2006">
+<p:notesMaster xmlns:a="http://schemas.openxmlformats.org/drawingml/2006/main" xmlns:r="http://schemas.openxmlformats.org/officeDocument/2006/relationships" xmlns:p="http://schemas.openxmlformats.org/presentationml/2006/main">
   <p:cSld>
+    <p:bg>
+      <p:bgRef idx="1001">
+        <a:schemeClr val="bg1"/>
+      </p:bgRef>
+    </p:bg>
     <p:spTree>
       <p:nvGrpSpPr>
         <p:cNvPr id="1" name=""/>
@@ -44,7 +144,7 @@
         <p:nvSpPr>
           <p:cNvPr id="43" name="PlaceHolder 1"/>
           <p:cNvSpPr>
-            <a:spLocks noGrp="1"/>
+            <a:spLocks noGrp="1" noRot="1" noChangeAspect="1"/>
           </p:cNvSpPr>
           <p:nvPr>
             <p:ph type="sldImg"/>
@@ -67,6 +167,7 @@
           <a:bodyPr lIns="0" tIns="0" rIns="0" bIns="0" anchor="ctr">
             <a:noAutofit/>
           </a:bodyPr>
+          <a:lstStyle/>
           <a:p>
             <a:pPr defTabSz="914400">
               <a:lnSpc>
@@ -84,14 +185,6 @@
               </a:rPr>
               <a:t>Click to move the slide</a:t>
             </a:r>
-            <a:endParaRPr lang="en-GB" sz="2600" b="1" u="none" strike="noStrike">
-              <a:solidFill>
-                <a:srgbClr val="1E3A5F"/>
-              </a:solidFill>
-              <a:effectLst/>
-              <a:uFillTx/>
-              <a:latin typeface="Cambria"/>
-            </a:endParaRPr>
           </a:p>
         </p:txBody>
       </p:sp>
@@ -122,6 +215,7 @@
           <a:bodyPr lIns="0" tIns="0" rIns="0" bIns="0" anchor="t">
             <a:noAutofit/>
           </a:bodyPr>
+          <a:lstStyle/>
           <a:p>
             <a:pPr indent="0" algn="l">
               <a:buNone/>
@@ -137,14 +231,6 @@
               </a:rPr>
               <a:t>Click to edit the notes' format</a:t>
             </a:r>
-            <a:endParaRPr lang="en-GB" sz="2000" b="0" u="none" strike="noStrike">
-              <a:solidFill>
-                <a:srgbClr val="000000"/>
-              </a:solidFill>
-              <a:effectLst/>
-              <a:uFillTx/>
-              <a:latin typeface="Arial"/>
-            </a:endParaRPr>
           </a:p>
         </p:txBody>
       </p:sp>
@@ -175,6 +261,7 @@
           <a:bodyPr lIns="0" tIns="0" rIns="0" bIns="0" anchor="t">
             <a:noAutofit/>
           </a:bodyPr>
+          <a:lstStyle/>
           <a:p>
             <a:pPr indent="0" algn="l">
               <a:buNone/>
@@ -190,14 +277,6 @@
               </a:rPr>
               <a:t>&lt;header&gt;</a:t>
             </a:r>
-            <a:endParaRPr lang="en-GB" sz="1400" b="0" u="none" strike="noStrike">
-              <a:solidFill>
-                <a:srgbClr val="000000"/>
-              </a:solidFill>
-              <a:effectLst/>
-              <a:uFillTx/>
-              <a:latin typeface="Times New Roman"/>
-            </a:endParaRPr>
           </a:p>
         </p:txBody>
       </p:sp>
@@ -256,14 +335,6 @@
               </a:rPr>
               <a:t>&lt;date/time&gt;</a:t>
             </a:r>
-            <a:endParaRPr lang="en-GB" sz="1400" b="0" u="none" strike="noStrike">
-              <a:solidFill>
-                <a:srgbClr val="000000"/>
-              </a:solidFill>
-              <a:effectLst/>
-              <a:uFillTx/>
-              <a:latin typeface="Times New Roman"/>
-            </a:endParaRPr>
           </a:p>
         </p:txBody>
       </p:sp>
@@ -322,14 +393,6 @@
               </a:rPr>
               <a:t>&lt;footer&gt;</a:t>
             </a:r>
-            <a:endParaRPr lang="en-GB" sz="1400" b="0" u="none" strike="noStrike">
-              <a:solidFill>
-                <a:srgbClr val="000000"/>
-              </a:solidFill>
-              <a:effectLst/>
-              <a:uFillTx/>
-              <a:latin typeface="Times New Roman"/>
-            </a:endParaRPr>
           </a:p>
         </p:txBody>
       </p:sp>
@@ -386,7 +449,7 @@
                 <a:uFillTx/>
                 <a:latin typeface="Times New Roman"/>
               </a:rPr>
-              <a:t>&lt;number&gt;</a:t>
+              <a:t>‹#›</a:t>
             </a:fld>
             <a:endParaRPr lang="en-GB" sz="1400" b="0" u="none" strike="noStrike">
               <a:solidFill>
@@ -401,12 +464,104 @@
       </p:sp>
     </p:spTree>
   </p:cSld>
-  <p:clrMap bg1="lt1" bg2="lt2" tx1="dk1" tx2="dk2" accent1="accent1" accent2="accent2" accent3="accent3" accent4="accent4" accent5="accent5" accent6="accent6" hlink="hlink" folHlink="folHlink"/>
+  <p:clrMap bg1="lt1" tx1="dk1" bg2="lt2" tx2="dk2" accent1="accent1" accent2="accent2" accent3="accent3" accent4="accent4" accent5="accent5" accent6="accent6" hlink="hlink" folHlink="folHlink"/>
+  <p:notesStyle>
+    <a:lvl1pPr marL="0" algn="l" defTabSz="914400" rtl="0" eaLnBrk="1" latinLnBrk="0" hangingPunct="1">
+      <a:defRPr sz="1200" kern="1200">
+        <a:solidFill>
+          <a:schemeClr val="tx1"/>
+        </a:solidFill>
+        <a:latin typeface="+mn-lt"/>
+        <a:ea typeface="+mn-ea"/>
+        <a:cs typeface="+mn-cs"/>
+      </a:defRPr>
+    </a:lvl1pPr>
+    <a:lvl2pPr marL="457200" algn="l" defTabSz="914400" rtl="0" eaLnBrk="1" latinLnBrk="0" hangingPunct="1">
+      <a:defRPr sz="1200" kern="1200">
+        <a:solidFill>
+          <a:schemeClr val="tx1"/>
+        </a:solidFill>
+        <a:latin typeface="+mn-lt"/>
+        <a:ea typeface="+mn-ea"/>
+        <a:cs typeface="+mn-cs"/>
+      </a:defRPr>
+    </a:lvl2pPr>
+    <a:lvl3pPr marL="914400" algn="l" defTabSz="914400" rtl="0" eaLnBrk="1" latinLnBrk="0" hangingPunct="1">
+      <a:defRPr sz="1200" kern="1200">
+        <a:solidFill>
+          <a:schemeClr val="tx1"/>
+        </a:solidFill>
+        <a:latin typeface="+mn-lt"/>
+        <a:ea typeface="+mn-ea"/>
+        <a:cs typeface="+mn-cs"/>
+      </a:defRPr>
+    </a:lvl3pPr>
+    <a:lvl4pPr marL="1371600" algn="l" defTabSz="914400" rtl="0" eaLnBrk="1" latinLnBrk="0" hangingPunct="1">
+      <a:defRPr sz="1200" kern="1200">
+        <a:solidFill>
+          <a:schemeClr val="tx1"/>
+        </a:solidFill>
+        <a:latin typeface="+mn-lt"/>
+        <a:ea typeface="+mn-ea"/>
+        <a:cs typeface="+mn-cs"/>
+      </a:defRPr>
+    </a:lvl4pPr>
+    <a:lvl5pPr marL="1828800" algn="l" defTabSz="914400" rtl="0" eaLnBrk="1" latinLnBrk="0" hangingPunct="1">
+      <a:defRPr sz="1200" kern="1200">
+        <a:solidFill>
+          <a:schemeClr val="tx1"/>
+        </a:solidFill>
+        <a:latin typeface="+mn-lt"/>
+        <a:ea typeface="+mn-ea"/>
+        <a:cs typeface="+mn-cs"/>
+      </a:defRPr>
+    </a:lvl5pPr>
+    <a:lvl6pPr marL="2286000" algn="l" defTabSz="914400" rtl="0" eaLnBrk="1" latinLnBrk="0" hangingPunct="1">
+      <a:defRPr sz="1200" kern="1200">
+        <a:solidFill>
+          <a:schemeClr val="tx1"/>
+        </a:solidFill>
+        <a:latin typeface="+mn-lt"/>
+        <a:ea typeface="+mn-ea"/>
+        <a:cs typeface="+mn-cs"/>
+      </a:defRPr>
+    </a:lvl6pPr>
+    <a:lvl7pPr marL="2743200" algn="l" defTabSz="914400" rtl="0" eaLnBrk="1" latinLnBrk="0" hangingPunct="1">
+      <a:defRPr sz="1200" kern="1200">
+        <a:solidFill>
+          <a:schemeClr val="tx1"/>
+        </a:solidFill>
+        <a:latin typeface="+mn-lt"/>
+        <a:ea typeface="+mn-ea"/>
+        <a:cs typeface="+mn-cs"/>
+      </a:defRPr>
+    </a:lvl7pPr>
+    <a:lvl8pPr marL="3200400" algn="l" defTabSz="914400" rtl="0" eaLnBrk="1" latinLnBrk="0" hangingPunct="1">
+      <a:defRPr sz="1200" kern="1200">
+        <a:solidFill>
+          <a:schemeClr val="tx1"/>
+        </a:solidFill>
+        <a:latin typeface="+mn-lt"/>
+        <a:ea typeface="+mn-ea"/>
+        <a:cs typeface="+mn-cs"/>
+      </a:defRPr>
+    </a:lvl8pPr>
+    <a:lvl9pPr marL="3657600" algn="l" defTabSz="914400" rtl="0" eaLnBrk="1" latinLnBrk="0" hangingPunct="1">
+      <a:defRPr sz="1200" kern="1200">
+        <a:solidFill>
+          <a:schemeClr val="tx1"/>
+        </a:solidFill>
+        <a:latin typeface="+mn-lt"/>
+        <a:ea typeface="+mn-ea"/>
+        <a:cs typeface="+mn-cs"/>
+      </a:defRPr>
+    </a:lvl9pPr>
+  </p:notesStyle>
 </p:notesMaster>
 </file>
 
 <file path=ppt/notesSlides/notesSlide1.xml><?xml version="1.0" encoding="utf-8"?>
-<p:notes xmlns:a="http://schemas.openxmlformats.org/drawingml/2006/main" xmlns:p="http://schemas.openxmlformats.org/presentationml/2006/main" xmlns:r="http://schemas.openxmlformats.org/officeDocument/2006/relationships" xmlns:p14="http://schemas.microsoft.com/office/powerpoint/2010/main" xmlns:p15="http://schemas.microsoft.com/office/powerpoint/2012/main" xmlns:mc="http://schemas.openxmlformats.org/markup-compatibility/2006">
+<p:notes xmlns:a="http://schemas.openxmlformats.org/drawingml/2006/main" xmlns:r="http://schemas.openxmlformats.org/officeDocument/2006/relationships" xmlns:p="http://schemas.openxmlformats.org/presentationml/2006/main">
   <p:cSld>
     <p:spTree>
       <p:nvGrpSpPr>
@@ -426,7 +581,7 @@
         <p:nvSpPr>
           <p:cNvPr id="85" name="PlaceHolder 1"/>
           <p:cNvSpPr>
-            <a:spLocks noGrp="1"/>
+            <a:spLocks noGrp="1" noRot="1" noChangeAspect="1"/>
           </p:cNvSpPr>
           <p:nvPr>
             <p:ph type="sldImg"/>
@@ -472,6 +627,7 @@
           <a:bodyPr lIns="90000" tIns="-45000" rIns="90000" bIns="-45000" anchor="t">
             <a:noAutofit/>
           </a:bodyPr>
+          <a:lstStyle/>
           <a:p>
             <a:pPr indent="0" algn="l">
               <a:buNone/>
@@ -548,7 +704,7 @@
                 <a:latin typeface="+mn-lt"/>
                 <a:ea typeface="+mn-ea"/>
               </a:rPr>
-              <a:t>&lt;number&gt;</a:t>
+              <a:t>1</a:t>
             </a:fld>
             <a:endParaRPr lang="en-GB" sz="1800" b="0" u="none" strike="noStrike">
               <a:solidFill>
@@ -563,11 +719,14 @@
       </p:sp>
     </p:spTree>
   </p:cSld>
+  <p:clrMapOvr>
+    <a:masterClrMapping/>
+  </p:clrMapOvr>
 </p:notes>
 </file>
 
 <file path=ppt/notesSlides/notesSlide2.xml><?xml version="1.0" encoding="utf-8"?>
-<p:notes xmlns:a="http://schemas.openxmlformats.org/drawingml/2006/main" xmlns:p="http://schemas.openxmlformats.org/presentationml/2006/main" xmlns:r="http://schemas.openxmlformats.org/officeDocument/2006/relationships" xmlns:p14="http://schemas.microsoft.com/office/powerpoint/2010/main" xmlns:p15="http://schemas.microsoft.com/office/powerpoint/2012/main" xmlns:mc="http://schemas.openxmlformats.org/markup-compatibility/2006">
+<p:notes xmlns:a="http://schemas.openxmlformats.org/drawingml/2006/main" xmlns:r="http://schemas.openxmlformats.org/officeDocument/2006/relationships" xmlns:p="http://schemas.openxmlformats.org/presentationml/2006/main">
   <p:cSld>
     <p:spTree>
       <p:nvGrpSpPr>
@@ -587,7 +746,7 @@
         <p:nvSpPr>
           <p:cNvPr id="88" name="PlaceHolder 1"/>
           <p:cNvSpPr>
-            <a:spLocks noGrp="1"/>
+            <a:spLocks noGrp="1" noRot="1" noChangeAspect="1"/>
           </p:cNvSpPr>
           <p:nvPr>
             <p:ph type="sldImg"/>
@@ -633,6 +792,7 @@
           <a:bodyPr lIns="90000" tIns="-45000" rIns="90000" bIns="-45000" anchor="t">
             <a:noAutofit/>
           </a:bodyPr>
+          <a:lstStyle/>
           <a:p>
             <a:pPr indent="0" algn="l">
               <a:buNone/>
@@ -709,7 +869,7 @@
                 <a:latin typeface="+mn-lt"/>
                 <a:ea typeface="+mn-ea"/>
               </a:rPr>
-              <a:t>&lt;number&gt;</a:t>
+              <a:t>2</a:t>
             </a:fld>
             <a:endParaRPr lang="en-GB" sz="1800" b="0" u="none" strike="noStrike">
               <a:solidFill>
@@ -724,17 +884,127 @@
       </p:sp>
     </p:spTree>
   </p:cSld>
+  <p:clrMapOvr>
+    <a:masterClrMapping/>
+  </p:clrMapOvr>
+</p:notes>
+</file>
+
+<file path=ppt/notesSlides/notesSlide3.xml><?xml version="1.0" encoding="utf-8"?>
+<p:notes xmlns:a="http://schemas.openxmlformats.org/drawingml/2006/main" xmlns:r="http://schemas.openxmlformats.org/officeDocument/2006/relationships" xmlns:p="http://schemas.openxmlformats.org/presentationml/2006/main">
+  <p:cSld>
+    <p:spTree>
+      <p:nvGrpSpPr>
+        <p:cNvPr id="1" name=""/>
+        <p:cNvGrpSpPr/>
+        <p:nvPr/>
+      </p:nvGrpSpPr>
+      <p:grpSpPr>
+        <a:xfrm>
+          <a:off x="0" y="0"/>
+          <a:ext cx="0" cy="0"/>
+          <a:chOff x="0" y="0"/>
+          <a:chExt cx="0" cy="0"/>
+        </a:xfrm>
+      </p:grpSpPr>
+      <p:sp>
+        <p:nvSpPr>
+          <p:cNvPr id="2" name="Platshållare för bildobjekt 1"/>
+          <p:cNvSpPr>
+            <a:spLocks noGrp="1" noRot="1" noChangeAspect="1"/>
+          </p:cNvSpPr>
+          <p:nvPr>
+            <p:ph type="sldImg"/>
+          </p:nvPr>
+        </p:nvSpPr>
+        <p:spPr>
+          <a:xfrm>
+            <a:off x="0" y="812800"/>
+            <a:ext cx="0" cy="0"/>
+          </a:xfrm>
+        </p:spPr>
+      </p:sp>
+      <p:sp>
+        <p:nvSpPr>
+          <p:cNvPr id="3" name="Platshållare för anteckningar 2"/>
+          <p:cNvSpPr>
+            <a:spLocks noGrp="1"/>
+          </p:cNvSpPr>
+          <p:nvPr>
+            <p:ph type="body" idx="1"/>
+          </p:nvPr>
+        </p:nvSpPr>
+        <p:spPr/>
+        <p:txBody>
+          <a:bodyPr/>
+          <a:lstStyle/>
+          <a:p>
+            <a:endParaRPr lang="en-SE" dirty="0"/>
+          </a:p>
+        </p:txBody>
+      </p:sp>
+      <p:sp>
+        <p:nvSpPr>
+          <p:cNvPr id="4" name="Platshållare för bildnummer 3"/>
+          <p:cNvSpPr>
+            <a:spLocks noGrp="1"/>
+          </p:cNvSpPr>
+          <p:nvPr>
+            <p:ph type="sldNum" idx="11"/>
+          </p:nvPr>
+        </p:nvSpPr>
+        <p:spPr/>
+        <p:txBody>
+          <a:bodyPr/>
+          <a:lstStyle/>
+          <a:p>
+            <a:pPr indent="0" algn="r">
+              <a:buNone/>
+            </a:pPr>
+            <a:fld id="{BA81C5BF-3759-4780-A09A-9C52D56FECE9}" type="slidenum">
+              <a:rPr lang="en-GB" sz="1400" b="0" u="none" strike="noStrike" smtClean="0">
+                <a:solidFill>
+                  <a:srgbClr val="000000"/>
+                </a:solidFill>
+                <a:effectLst/>
+                <a:uFillTx/>
+                <a:latin typeface="Times New Roman"/>
+              </a:rPr>
+              <a:t>7</a:t>
+            </a:fld>
+            <a:endParaRPr lang="en-GB" sz="1400" b="0" u="none" strike="noStrike">
+              <a:solidFill>
+                <a:srgbClr val="000000"/>
+              </a:solidFill>
+              <a:effectLst/>
+              <a:uFillTx/>
+              <a:latin typeface="Times New Roman"/>
+            </a:endParaRPr>
+          </a:p>
+        </p:txBody>
+      </p:sp>
+    </p:spTree>
+    <p:extLst>
+      <p:ext uri="{BB962C8B-B14F-4D97-AF65-F5344CB8AC3E}">
+        <p14:creationId xmlns:p14="http://schemas.microsoft.com/office/powerpoint/2010/main" val="1300500767"/>
+      </p:ext>
+    </p:extLst>
+  </p:cSld>
+  <p:clrMapOvr>
+    <a:masterClrMapping/>
+  </p:clrMapOvr>
 </p:notes>
 </file>
 
 <file path=ppt/slideLayouts/slideLayout1.xml><?xml version="1.0" encoding="utf-8"?>
-<p:sldLayout xmlns:a="http://schemas.openxmlformats.org/drawingml/2006/main" xmlns:p="http://schemas.openxmlformats.org/presentationml/2006/main" xmlns:r="http://schemas.openxmlformats.org/officeDocument/2006/relationships" xmlns:p14="http://schemas.microsoft.com/office/powerpoint/2010/main" xmlns:p15="http://schemas.microsoft.com/office/powerpoint/2012/main" xmlns:mc="http://schemas.openxmlformats.org/markup-compatibility/2006" type="blank" preserve="1">
+<p:sldLayout xmlns:a="http://schemas.openxmlformats.org/drawingml/2006/main" xmlns:r="http://schemas.openxmlformats.org/officeDocument/2006/relationships" xmlns:p="http://schemas.openxmlformats.org/presentationml/2006/main" type="blank" preserve="1">
   <p:cSld name="Rubrik och innehåll">
     <p:bg>
       <p:bgPr>
         <a:solidFill>
           <a:srgbClr val="FFFFFF"/>
         </a:solidFill>
+        <a:effectLst/>
       </p:bgPr>
     </p:bg>
     <p:spTree>
@@ -867,15 +1137,22 @@
           </a:ln>
         </p:spPr>
         <p:style>
-          <a:lnRef idx="0"/>
-          <a:fillRef idx="0"/>
-          <a:effectRef idx="0"/>
+          <a:lnRef idx="0">
+            <a:scrgbClr r="0" g="0" b="0"/>
+          </a:lnRef>
+          <a:fillRef idx="0">
+            <a:scrgbClr r="0" g="0" b="0"/>
+          </a:fillRef>
+          <a:effectRef idx="0">
+            <a:scrgbClr r="0" g="0" b="0"/>
+          </a:effectRef>
           <a:fontRef idx="minor"/>
         </p:style>
         <p:txBody>
           <a:bodyPr lIns="0" tIns="0" rIns="0" bIns="0" anchor="ctr">
             <a:noAutofit/>
           </a:bodyPr>
+          <a:lstStyle/>
           <a:p>
             <a:pPr defTabSz="914400">
               <a:lnSpc>
@@ -895,19 +1172,7 @@
                 <a:latin typeface="Calibri"/>
                 <a:ea typeface="Calibri"/>
               </a:rPr>
-              <a:t>FSE 2026  ·  Montréal  ·  5–9 </a:t>
-            </a:r>
-            <a:r>
-              <a:rPr lang="en-US" sz="900" b="0" u="none" strike="noStrike">
-                <a:solidFill>
-                  <a:srgbClr val="7A8794"/>
-                </a:solidFill>
-                <a:effectLst/>
-                <a:uFillTx/>
-                <a:latin typeface="Calibri"/>
-                <a:ea typeface="Calibri"/>
-              </a:rPr>
-              <a:t>July 2026</a:t>
+              <a:t>FSE 2026  ·  Montréal  ·  5–9 July 2026</a:t>
             </a:r>
             <a:endParaRPr lang="en-GB" sz="900" b="0" u="none" strike="noStrike">
               <a:solidFill>
@@ -975,14 +1240,6 @@
               </a:rPr>
               <a:t>Causal Effect Estimation</a:t>
             </a:r>
-            <a:endParaRPr lang="en-GB" sz="1400" b="0" u="none" strike="noStrike">
-              <a:solidFill>
-                <a:srgbClr val="000000"/>
-              </a:solidFill>
-              <a:effectLst/>
-              <a:uFillTx/>
-              <a:latin typeface="Times New Roman"/>
-            </a:endParaRPr>
           </a:p>
         </p:txBody>
       </p:sp>
@@ -1437,7 +1694,7 @@
                 <a:latin typeface="Calibri"/>
                 <a:ea typeface="Calibri"/>
               </a:rPr>
-              <a:t>6</a:t>
+              <a:t>‹#›</a:t>
             </a:fld>
             <a:endParaRPr lang="en-GB" sz="900" b="0" u="none" strike="noStrike">
               <a:solidFill>
@@ -1452,17 +1709,21 @@
       </p:sp>
     </p:spTree>
   </p:cSld>
+  <p:clrMapOvr>
+    <a:masterClrMapping/>
+  </p:clrMapOvr>
 </p:sldLayout>
 </file>
 
 <file path=ppt/slideLayouts/slideLayout2.xml><?xml version="1.0" encoding="utf-8"?>
-<p:sldLayout xmlns:a="http://schemas.openxmlformats.org/drawingml/2006/main" xmlns:p="http://schemas.openxmlformats.org/presentationml/2006/main" xmlns:r="http://schemas.openxmlformats.org/officeDocument/2006/relationships" xmlns:p14="http://schemas.microsoft.com/office/powerpoint/2010/main" xmlns:p15="http://schemas.microsoft.com/office/powerpoint/2012/main" xmlns:mc="http://schemas.openxmlformats.org/markup-compatibility/2006" type="blank" preserve="1">
+<p:sldLayout xmlns:a="http://schemas.openxmlformats.org/drawingml/2006/main" xmlns:r="http://schemas.openxmlformats.org/officeDocument/2006/relationships" xmlns:p="http://schemas.openxmlformats.org/presentationml/2006/main" type="blank" preserve="1">
   <p:cSld name="Endast rubrik">
     <p:bg>
       <p:bgPr>
         <a:solidFill>
           <a:srgbClr val="FFFFFF"/>
         </a:solidFill>
+        <a:effectLst/>
       </p:bgPr>
     </p:bg>
     <p:spTree>
@@ -1595,15 +1856,22 @@
           </a:ln>
         </p:spPr>
         <p:style>
-          <a:lnRef idx="0"/>
-          <a:fillRef idx="0"/>
-          <a:effectRef idx="0"/>
+          <a:lnRef idx="0">
+            <a:scrgbClr r="0" g="0" b="0"/>
+          </a:lnRef>
+          <a:fillRef idx="0">
+            <a:scrgbClr r="0" g="0" b="0"/>
+          </a:fillRef>
+          <a:effectRef idx="0">
+            <a:scrgbClr r="0" g="0" b="0"/>
+          </a:effectRef>
           <a:fontRef idx="minor"/>
         </p:style>
         <p:txBody>
           <a:bodyPr lIns="0" tIns="0" rIns="0" bIns="0" anchor="ctr">
             <a:noAutofit/>
           </a:bodyPr>
+          <a:lstStyle/>
           <a:p>
             <a:pPr defTabSz="914400">
               <a:lnSpc>
@@ -1691,14 +1959,6 @@
               </a:rPr>
               <a:t>Causal Effect Estimation</a:t>
             </a:r>
-            <a:endParaRPr lang="en-GB" sz="1400" b="0" u="none" strike="noStrike">
-              <a:solidFill>
-                <a:srgbClr val="000000"/>
-              </a:solidFill>
-              <a:effectLst/>
-              <a:uFillTx/>
-              <a:latin typeface="Times New Roman"/>
-            </a:endParaRPr>
           </a:p>
         </p:txBody>
       </p:sp>
@@ -1763,67 +2023,7 @@
                 <a:latin typeface="Cambria"/>
                 <a:ea typeface="Cambria"/>
               </a:rPr>
-              <a:t>Klicka </a:t>
-            </a:r>
-            <a:r>
-              <a:rPr lang="sv-SE" sz="2600" b="1" u="none" strike="noStrike">
-                <a:solidFill>
-                  <a:srgbClr val="1E3A5F"/>
-                </a:solidFill>
-                <a:effectLst/>
-                <a:uFillTx/>
-                <a:latin typeface="Cambria"/>
-                <a:ea typeface="Cambria"/>
-              </a:rPr>
-              <a:t>här för </a:t>
-            </a:r>
-            <a:r>
-              <a:rPr lang="sv-SE" sz="2600" b="1" u="none" strike="noStrike">
-                <a:solidFill>
-                  <a:srgbClr val="1E3A5F"/>
-                </a:solidFill>
-                <a:effectLst/>
-                <a:uFillTx/>
-                <a:latin typeface="Cambria"/>
-                <a:ea typeface="Cambria"/>
-              </a:rPr>
-              <a:t>att ändra </a:t>
-            </a:r>
-            <a:r>
-              <a:rPr lang="sv-SE" sz="2600" b="1" u="none" strike="noStrike">
-                <a:solidFill>
-                  <a:srgbClr val="1E3A5F"/>
-                </a:solidFill>
-                <a:effectLst/>
-                <a:uFillTx/>
-                <a:latin typeface="Cambria"/>
-                <a:ea typeface="Cambria"/>
-              </a:rPr>
-              <a:t>mall för </a:t>
-            </a:r>
-            <a:r>
-              <a:rPr lang="sv-SE" sz="2600" b="1" u="none" strike="noStrike">
-                <a:solidFill>
-                  <a:srgbClr val="1E3A5F"/>
-                </a:solidFill>
-                <a:effectLst/>
-                <a:uFillTx/>
-                <a:latin typeface="Cambria"/>
-                <a:ea typeface="Cambria"/>
-              </a:rPr>
-              <a:t>rubrikfo</a:t>
-            </a:r>
-            <a:r>
-              <a:rPr lang="sv-SE" sz="2600" b="1" u="none" strike="noStrike">
-                <a:solidFill>
-                  <a:srgbClr val="1E3A5F"/>
-                </a:solidFill>
-                <a:effectLst/>
-                <a:uFillTx/>
-                <a:latin typeface="Cambria"/>
-                <a:ea typeface="Cambria"/>
-              </a:rPr>
-              <a:t>rmat</a:t>
+              <a:t>Klicka här för att ändra mall för rubrikformat</a:t>
             </a:r>
             <a:endParaRPr lang="en-GB" sz="2600" b="1" u="none" strike="noStrike">
               <a:solidFill>
@@ -1897,7 +2097,7 @@
                 <a:latin typeface="Calibri"/>
                 <a:ea typeface="Calibri"/>
               </a:rPr>
-              <a:t>6</a:t>
+              <a:t>‹#›</a:t>
             </a:fld>
             <a:endParaRPr lang="en-GB" sz="900" b="0" u="none" strike="noStrike">
               <a:solidFill>
@@ -1912,17 +2112,21 @@
       </p:sp>
     </p:spTree>
   </p:cSld>
+  <p:clrMapOvr>
+    <a:masterClrMapping/>
+  </p:clrMapOvr>
 </p:sldLayout>
 </file>
 
 <file path=ppt/slideLayouts/slideLayout3.xml><?xml version="1.0" encoding="utf-8"?>
-<p:sldLayout xmlns:a="http://schemas.openxmlformats.org/drawingml/2006/main" xmlns:p="http://schemas.openxmlformats.org/presentationml/2006/main" xmlns:r="http://schemas.openxmlformats.org/officeDocument/2006/relationships" xmlns:p14="http://schemas.microsoft.com/office/powerpoint/2010/main" xmlns:p15="http://schemas.microsoft.com/office/powerpoint/2012/main" xmlns:mc="http://schemas.openxmlformats.org/markup-compatibility/2006" type="blank" preserve="1">
+<p:sldLayout xmlns:a="http://schemas.openxmlformats.org/drawingml/2006/main" xmlns:r="http://schemas.openxmlformats.org/officeDocument/2006/relationships" xmlns:p="http://schemas.openxmlformats.org/presentationml/2006/main" type="blank" preserve="1">
   <p:cSld name="Två delar">
     <p:bg>
       <p:bgPr>
         <a:solidFill>
           <a:srgbClr val="FFFFFF"/>
         </a:solidFill>
+        <a:effectLst/>
       </p:bgPr>
     </p:bg>
     <p:spTree>
@@ -2055,15 +2259,22 @@
           </a:ln>
         </p:spPr>
         <p:style>
-          <a:lnRef idx="0"/>
-          <a:fillRef idx="0"/>
-          <a:effectRef idx="0"/>
+          <a:lnRef idx="0">
+            <a:scrgbClr r="0" g="0" b="0"/>
+          </a:lnRef>
+          <a:fillRef idx="0">
+            <a:scrgbClr r="0" g="0" b="0"/>
+          </a:fillRef>
+          <a:effectRef idx="0">
+            <a:scrgbClr r="0" g="0" b="0"/>
+          </a:effectRef>
           <a:fontRef idx="minor"/>
         </p:style>
         <p:txBody>
           <a:bodyPr lIns="0" tIns="0" rIns="0" bIns="0" anchor="ctr">
             <a:noAutofit/>
           </a:bodyPr>
+          <a:lstStyle/>
           <a:p>
             <a:pPr defTabSz="914400">
               <a:lnSpc>
@@ -2783,14 +2994,6 @@
               </a:rPr>
               <a:t>Causal Effect Estimation</a:t>
             </a:r>
-            <a:endParaRPr lang="en-GB" sz="1400" b="0" u="none" strike="noStrike">
-              <a:solidFill>
-                <a:srgbClr val="000000"/>
-              </a:solidFill>
-              <a:effectLst/>
-              <a:uFillTx/>
-              <a:latin typeface="Times New Roman"/>
-            </a:endParaRPr>
           </a:p>
         </p:txBody>
       </p:sp>
@@ -2929,7 +3132,7 @@
                 <a:latin typeface="Calibri"/>
                 <a:ea typeface="Calibri"/>
               </a:rPr>
-              <a:t>6</a:t>
+              <a:t>‹#›</a:t>
             </a:fld>
             <a:endParaRPr lang="en-GB" sz="900" b="0" u="none" strike="noStrike">
               <a:solidFill>
@@ -2944,17 +3147,21 @@
       </p:sp>
     </p:spTree>
   </p:cSld>
+  <p:clrMapOvr>
+    <a:masterClrMapping/>
+  </p:clrMapOvr>
 </p:sldLayout>
 </file>
 
 <file path=ppt/slideLayouts/slideLayout4.xml><?xml version="1.0" encoding="utf-8"?>
-<p:sldLayout xmlns:a="http://schemas.openxmlformats.org/drawingml/2006/main" xmlns:p="http://schemas.openxmlformats.org/presentationml/2006/main" xmlns:r="http://schemas.openxmlformats.org/officeDocument/2006/relationships" xmlns:p14="http://schemas.microsoft.com/office/powerpoint/2010/main" xmlns:p15="http://schemas.microsoft.com/office/powerpoint/2012/main" xmlns:mc="http://schemas.openxmlformats.org/markup-compatibility/2006" type="blank" preserve="1">
+<p:sldLayout xmlns:a="http://schemas.openxmlformats.org/drawingml/2006/main" xmlns:r="http://schemas.openxmlformats.org/officeDocument/2006/relationships" xmlns:p="http://schemas.openxmlformats.org/presentationml/2006/main" type="blank" preserve="1">
   <p:cSld name="Rubrikbild">
     <p:bg>
       <p:bgPr>
         <a:solidFill>
           <a:srgbClr val="FFFFFF"/>
         </a:solidFill>
+        <a:effectLst/>
       </p:bgPr>
     </p:bg>
     <p:spTree>
@@ -3087,15 +3294,22 @@
           </a:ln>
         </p:spPr>
         <p:style>
-          <a:lnRef idx="0"/>
-          <a:fillRef idx="0"/>
-          <a:effectRef idx="0"/>
+          <a:lnRef idx="0">
+            <a:scrgbClr r="0" g="0" b="0"/>
+          </a:lnRef>
+          <a:fillRef idx="0">
+            <a:scrgbClr r="0" g="0" b="0"/>
+          </a:fillRef>
+          <a:effectRef idx="0">
+            <a:scrgbClr r="0" g="0" b="0"/>
+          </a:effectRef>
           <a:fontRef idx="minor"/>
         </p:style>
         <p:txBody>
           <a:bodyPr lIns="0" tIns="0" rIns="0" bIns="0" anchor="ctr">
             <a:noAutofit/>
           </a:bodyPr>
+          <a:lstStyle/>
           <a:p>
             <a:pPr defTabSz="914400">
               <a:lnSpc>
@@ -3183,14 +3397,6 @@
               </a:rPr>
               <a:t>Causal Effect Estimation</a:t>
             </a:r>
-            <a:endParaRPr lang="en-GB" sz="1400" b="0" u="none" strike="noStrike">
-              <a:solidFill>
-                <a:srgbClr val="000000"/>
-              </a:solidFill>
-              <a:effectLst/>
-              <a:uFillTx/>
-              <a:latin typeface="Times New Roman"/>
-            </a:endParaRPr>
           </a:p>
         </p:txBody>
       </p:sp>
@@ -3255,7 +3461,7 @@
                 <a:latin typeface="Calibri"/>
                 <a:ea typeface="Calibri"/>
               </a:rPr>
-              <a:t>6</a:t>
+              <a:t>‹#›</a:t>
             </a:fld>
             <a:endParaRPr lang="en-GB" sz="900" b="0" u="none" strike="noStrike">
               <a:solidFill>
@@ -3270,17 +3476,21 @@
       </p:sp>
     </p:spTree>
   </p:cSld>
+  <p:clrMapOvr>
+    <a:masterClrMapping/>
+  </p:clrMapOvr>
 </p:sldLayout>
 </file>
 
 <file path=ppt/slideLayouts/slideLayout5.xml><?xml version="1.0" encoding="utf-8"?>
-<p:sldLayout xmlns:a="http://schemas.openxmlformats.org/drawingml/2006/main" xmlns:p="http://schemas.openxmlformats.org/presentationml/2006/main" xmlns:r="http://schemas.openxmlformats.org/officeDocument/2006/relationships" xmlns:p14="http://schemas.microsoft.com/office/powerpoint/2010/main" xmlns:p15="http://schemas.microsoft.com/office/powerpoint/2012/main" xmlns:mc="http://schemas.openxmlformats.org/markup-compatibility/2006" type="blank" preserve="1">
+<p:sldLayout xmlns:a="http://schemas.openxmlformats.org/drawingml/2006/main" xmlns:r="http://schemas.openxmlformats.org/officeDocument/2006/relationships" xmlns:p="http://schemas.openxmlformats.org/presentationml/2006/main" type="blank" preserve="1">
   <p:cSld name="DEFAULT">
     <p:bg>
       <p:bgPr>
         <a:solidFill>
           <a:srgbClr val="FFFFFF"/>
         </a:solidFill>
+        <a:effectLst/>
       </p:bgPr>
     </p:bg>
     <p:spTree>
@@ -3413,15 +3623,22 @@
           </a:ln>
         </p:spPr>
         <p:style>
-          <a:lnRef idx="0"/>
-          <a:fillRef idx="0"/>
-          <a:effectRef idx="0"/>
+          <a:lnRef idx="0">
+            <a:scrgbClr r="0" g="0" b="0"/>
+          </a:lnRef>
+          <a:fillRef idx="0">
+            <a:scrgbClr r="0" g="0" b="0"/>
+          </a:fillRef>
+          <a:effectRef idx="0">
+            <a:scrgbClr r="0" g="0" b="0"/>
+          </a:effectRef>
           <a:fontRef idx="minor"/>
         </p:style>
         <p:txBody>
           <a:bodyPr lIns="0" tIns="0" rIns="0" bIns="0" anchor="ctr">
             <a:noAutofit/>
           </a:bodyPr>
+          <a:lstStyle/>
           <a:p>
             <a:pPr defTabSz="914400">
               <a:lnSpc>
@@ -3515,14 +3732,6 @@
               </a:rPr>
               <a:t>Click to edit the title text format</a:t>
             </a:r>
-            <a:endParaRPr lang="en-GB" sz="2600" b="1" u="none" strike="noStrike">
-              <a:solidFill>
-                <a:srgbClr val="1E3A5F"/>
-              </a:solidFill>
-              <a:effectLst/>
-              <a:uFillTx/>
-              <a:latin typeface="Cambria"/>
-            </a:endParaRPr>
           </a:p>
         </p:txBody>
       </p:sp>
@@ -3735,14 +3944,6 @@
               </a:rPr>
               <a:t>Click to edit the outline text format</a:t>
             </a:r>
-            <a:endParaRPr lang="en-GB" sz="2000" b="0" u="none" strike="noStrike">
-              <a:solidFill>
-                <a:schemeClr val="dk1"/>
-              </a:solidFill>
-              <a:effectLst/>
-              <a:uFillTx/>
-              <a:latin typeface="Calibri"/>
-            </a:endParaRPr>
           </a:p>
           <a:p>
             <a:pPr marL="864000" lvl="1" indent="-324000" algn="l">
@@ -3770,14 +3971,6 @@
               </a:rPr>
               <a:t>Second Outline Level</a:t>
             </a:r>
-            <a:endParaRPr lang="en-GB" sz="1600" b="0" u="none" strike="noStrike">
-              <a:solidFill>
-                <a:schemeClr val="dk1"/>
-              </a:solidFill>
-              <a:effectLst/>
-              <a:uFillTx/>
-              <a:latin typeface="Calibri"/>
-            </a:endParaRPr>
           </a:p>
           <a:p>
             <a:pPr marL="1296000" lvl="2" indent="-288000" algn="l">
@@ -3805,14 +3998,6 @@
               </a:rPr>
               <a:t>Third Outline Level</a:t>
             </a:r>
-            <a:endParaRPr lang="en-GB" sz="1600" b="0" u="none" strike="noStrike">
-              <a:solidFill>
-                <a:schemeClr val="dk1"/>
-              </a:solidFill>
-              <a:effectLst/>
-              <a:uFillTx/>
-              <a:latin typeface="Calibri"/>
-            </a:endParaRPr>
           </a:p>
           <a:p>
             <a:pPr marL="1728000" lvl="3" indent="-216000" algn="l">
@@ -3840,14 +4025,6 @@
               </a:rPr>
               <a:t>Fourth Outline Level</a:t>
             </a:r>
-            <a:endParaRPr lang="en-GB" sz="1600" b="0" u="none" strike="noStrike">
-              <a:solidFill>
-                <a:schemeClr val="dk1"/>
-              </a:solidFill>
-              <a:effectLst/>
-              <a:uFillTx/>
-              <a:latin typeface="Calibri"/>
-            </a:endParaRPr>
           </a:p>
           <a:p>
             <a:pPr marL="2160000" lvl="4" indent="-216000" algn="l">
@@ -3875,14 +4052,6 @@
               </a:rPr>
               <a:t>Fifth Outline Level</a:t>
             </a:r>
-            <a:endParaRPr lang="en-GB" sz="2000" b="0" u="none" strike="noStrike">
-              <a:solidFill>
-                <a:schemeClr val="dk1"/>
-              </a:solidFill>
-              <a:effectLst/>
-              <a:uFillTx/>
-              <a:latin typeface="Calibri"/>
-            </a:endParaRPr>
           </a:p>
           <a:p>
             <a:pPr marL="2592000" lvl="5" indent="-216000" algn="l">
@@ -3910,14 +4079,6 @@
               </a:rPr>
               <a:t>Sixth Outline Level</a:t>
             </a:r>
-            <a:endParaRPr lang="en-GB" sz="2000" b="0" u="none" strike="noStrike">
-              <a:solidFill>
-                <a:schemeClr val="dk1"/>
-              </a:solidFill>
-              <a:effectLst/>
-              <a:uFillTx/>
-              <a:latin typeface="Calibri"/>
-            </a:endParaRPr>
           </a:p>
           <a:p>
             <a:pPr marL="3024000" lvl="6" indent="-216000" algn="l">
@@ -3945,25 +4106,25 @@
               </a:rPr>
               <a:t>Seventh Outline Level</a:t>
             </a:r>
-            <a:endParaRPr lang="en-GB" sz="2000" b="0" u="none" strike="noStrike">
-              <a:solidFill>
-                <a:schemeClr val="dk1"/>
-              </a:solidFill>
-              <a:effectLst/>
-              <a:uFillTx/>
-              <a:latin typeface="Calibri"/>
-            </a:endParaRPr>
           </a:p>
         </p:txBody>
       </p:sp>
     </p:spTree>
   </p:cSld>
+  <p:clrMapOvr>
+    <a:masterClrMapping/>
+  </p:clrMapOvr>
 </p:sldLayout>
 </file>
 
 <file path=ppt/slideMasters/slideMaster1.xml><?xml version="1.0" encoding="utf-8"?>
-<p:sldMaster xmlns:a="http://schemas.openxmlformats.org/drawingml/2006/main" xmlns:p="http://schemas.openxmlformats.org/presentationml/2006/main" xmlns:r="http://schemas.openxmlformats.org/officeDocument/2006/relationships" xmlns:p14="http://schemas.microsoft.com/office/powerpoint/2010/main" xmlns:p15="http://schemas.microsoft.com/office/powerpoint/2012/main" xmlns:mc="http://schemas.openxmlformats.org/markup-compatibility/2006">
+<p:sldMaster xmlns:a="http://schemas.openxmlformats.org/drawingml/2006/main" xmlns:r="http://schemas.openxmlformats.org/officeDocument/2006/relationships" xmlns:p="http://schemas.openxmlformats.org/presentationml/2006/main">
   <p:cSld>
+    <p:bg>
+      <p:bgRef idx="1001">
+        <a:schemeClr val="bg1"/>
+      </p:bgRef>
+    </p:bg>
     <p:spTree>
       <p:nvGrpSpPr>
         <p:cNvPr id="1" name=""/>
@@ -3982,23 +4143,304 @@
   </p:cSld>
   <p:clrMap bg1="lt1" tx1="dk1" bg2="lt2" tx2="dk2" accent1="accent1" accent2="accent2" accent3="accent3" accent4="accent4" accent5="accent5" accent6="accent6" hlink="hlink" folHlink="folHlink"/>
   <p:sldLayoutIdLst>
-    <p:sldLayoutId id="2147483649" r:id="rId2"/>
-    <p:sldLayoutId id="2147483650" r:id="rId3"/>
-    <p:sldLayoutId id="2147483651" r:id="rId4"/>
-    <p:sldLayoutId id="2147483652" r:id="rId5"/>
-    <p:sldLayoutId id="2147483653" r:id="rId6"/>
+    <p:sldLayoutId id="2147483649" r:id="rId1"/>
+    <p:sldLayoutId id="2147483650" r:id="rId2"/>
+    <p:sldLayoutId id="2147483651" r:id="rId3"/>
+    <p:sldLayoutId id="2147483652" r:id="rId4"/>
+    <p:sldLayoutId id="2147483653" r:id="rId5"/>
   </p:sldLayoutIdLst>
+  <p:txStyles>
+    <p:titleStyle>
+      <a:lvl1pPr algn="l" defTabSz="914400" rtl="0" eaLnBrk="1" latinLnBrk="0" hangingPunct="1">
+        <a:lnSpc>
+          <a:spcPct val="90000"/>
+        </a:lnSpc>
+        <a:spcBef>
+          <a:spcPct val="0"/>
+        </a:spcBef>
+        <a:buNone/>
+        <a:defRPr sz="4400" kern="1200">
+          <a:solidFill>
+            <a:schemeClr val="tx1"/>
+          </a:solidFill>
+          <a:latin typeface="+mj-lt"/>
+          <a:ea typeface="+mj-ea"/>
+          <a:cs typeface="+mj-cs"/>
+        </a:defRPr>
+      </a:lvl1pPr>
+    </p:titleStyle>
+    <p:bodyStyle>
+      <a:lvl1pPr marL="228600" indent="-228600" algn="l" defTabSz="914400" rtl="0" eaLnBrk="1" latinLnBrk="0" hangingPunct="1">
+        <a:lnSpc>
+          <a:spcPct val="90000"/>
+        </a:lnSpc>
+        <a:spcBef>
+          <a:spcPts val="1000"/>
+        </a:spcBef>
+        <a:buFont typeface="Arial" panose="020B0604020202020204" pitchFamily="34" charset="0"/>
+        <a:buChar char="•"/>
+        <a:defRPr sz="2800" kern="1200">
+          <a:solidFill>
+            <a:schemeClr val="tx1"/>
+          </a:solidFill>
+          <a:latin typeface="+mn-lt"/>
+          <a:ea typeface="+mn-ea"/>
+          <a:cs typeface="+mn-cs"/>
+        </a:defRPr>
+      </a:lvl1pPr>
+      <a:lvl2pPr marL="685800" indent="-228600" algn="l" defTabSz="914400" rtl="0" eaLnBrk="1" latinLnBrk="0" hangingPunct="1">
+        <a:lnSpc>
+          <a:spcPct val="90000"/>
+        </a:lnSpc>
+        <a:spcBef>
+          <a:spcPts val="500"/>
+        </a:spcBef>
+        <a:buFont typeface="Arial" panose="020B0604020202020204" pitchFamily="34" charset="0"/>
+        <a:buChar char="•"/>
+        <a:defRPr sz="2400" kern="1200">
+          <a:solidFill>
+            <a:schemeClr val="tx1"/>
+          </a:solidFill>
+          <a:latin typeface="+mn-lt"/>
+          <a:ea typeface="+mn-ea"/>
+          <a:cs typeface="+mn-cs"/>
+        </a:defRPr>
+      </a:lvl2pPr>
+      <a:lvl3pPr marL="1143000" indent="-228600" algn="l" defTabSz="914400" rtl="0" eaLnBrk="1" latinLnBrk="0" hangingPunct="1">
+        <a:lnSpc>
+          <a:spcPct val="90000"/>
+        </a:lnSpc>
+        <a:spcBef>
+          <a:spcPts val="500"/>
+        </a:spcBef>
+        <a:buFont typeface="Arial" panose="020B0604020202020204" pitchFamily="34" charset="0"/>
+        <a:buChar char="•"/>
+        <a:defRPr sz="2000" kern="1200">
+          <a:solidFill>
+            <a:schemeClr val="tx1"/>
+          </a:solidFill>
+          <a:latin typeface="+mn-lt"/>
+          <a:ea typeface="+mn-ea"/>
+          <a:cs typeface="+mn-cs"/>
+        </a:defRPr>
+      </a:lvl3pPr>
+      <a:lvl4pPr marL="1600200" indent="-228600" algn="l" defTabSz="914400" rtl="0" eaLnBrk="1" latinLnBrk="0" hangingPunct="1">
+        <a:lnSpc>
+          <a:spcPct val="90000"/>
+        </a:lnSpc>
+        <a:spcBef>
+          <a:spcPts val="500"/>
+        </a:spcBef>
+        <a:buFont typeface="Arial" panose="020B0604020202020204" pitchFamily="34" charset="0"/>
+        <a:buChar char="•"/>
+        <a:defRPr sz="1800" kern="1200">
+          <a:solidFill>
+            <a:schemeClr val="tx1"/>
+          </a:solidFill>
+          <a:latin typeface="+mn-lt"/>
+          <a:ea typeface="+mn-ea"/>
+          <a:cs typeface="+mn-cs"/>
+        </a:defRPr>
+      </a:lvl4pPr>
+      <a:lvl5pPr marL="2057400" indent="-228600" algn="l" defTabSz="914400" rtl="0" eaLnBrk="1" latinLnBrk="0" hangingPunct="1">
+        <a:lnSpc>
+          <a:spcPct val="90000"/>
+        </a:lnSpc>
+        <a:spcBef>
+          <a:spcPts val="500"/>
+        </a:spcBef>
+        <a:buFont typeface="Arial" panose="020B0604020202020204" pitchFamily="34" charset="0"/>
+        <a:buChar char="•"/>
+        <a:defRPr sz="1800" kern="1200">
+          <a:solidFill>
+            <a:schemeClr val="tx1"/>
+          </a:solidFill>
+          <a:latin typeface="+mn-lt"/>
+          <a:ea typeface="+mn-ea"/>
+          <a:cs typeface="+mn-cs"/>
+        </a:defRPr>
+      </a:lvl5pPr>
+      <a:lvl6pPr marL="2514600" indent="-228600" algn="l" defTabSz="914400" rtl="0" eaLnBrk="1" latinLnBrk="0" hangingPunct="1">
+        <a:lnSpc>
+          <a:spcPct val="90000"/>
+        </a:lnSpc>
+        <a:spcBef>
+          <a:spcPts val="500"/>
+        </a:spcBef>
+        <a:buFont typeface="Arial" panose="020B0604020202020204" pitchFamily="34" charset="0"/>
+        <a:buChar char="•"/>
+        <a:defRPr sz="1800" kern="1200">
+          <a:solidFill>
+            <a:schemeClr val="tx1"/>
+          </a:solidFill>
+          <a:latin typeface="+mn-lt"/>
+          <a:ea typeface="+mn-ea"/>
+          <a:cs typeface="+mn-cs"/>
+        </a:defRPr>
+      </a:lvl6pPr>
+      <a:lvl7pPr marL="2971800" indent="-228600" algn="l" defTabSz="914400" rtl="0" eaLnBrk="1" latinLnBrk="0" hangingPunct="1">
+        <a:lnSpc>
+          <a:spcPct val="90000"/>
+        </a:lnSpc>
+        <a:spcBef>
+          <a:spcPts val="500"/>
+        </a:spcBef>
+        <a:buFont typeface="Arial" panose="020B0604020202020204" pitchFamily="34" charset="0"/>
+        <a:buChar char="•"/>
+        <a:defRPr sz="1800" kern="1200">
+          <a:solidFill>
+            <a:schemeClr val="tx1"/>
+          </a:solidFill>
+          <a:latin typeface="+mn-lt"/>
+          <a:ea typeface="+mn-ea"/>
+          <a:cs typeface="+mn-cs"/>
+        </a:defRPr>
+      </a:lvl7pPr>
+      <a:lvl8pPr marL="3429000" indent="-228600" algn="l" defTabSz="914400" rtl="0" eaLnBrk="1" latinLnBrk="0" hangingPunct="1">
+        <a:lnSpc>
+          <a:spcPct val="90000"/>
+        </a:lnSpc>
+        <a:spcBef>
+          <a:spcPts val="500"/>
+        </a:spcBef>
+        <a:buFont typeface="Arial" panose="020B0604020202020204" pitchFamily="34" charset="0"/>
+        <a:buChar char="•"/>
+        <a:defRPr sz="1800" kern="1200">
+          <a:solidFill>
+            <a:schemeClr val="tx1"/>
+          </a:solidFill>
+          <a:latin typeface="+mn-lt"/>
+          <a:ea typeface="+mn-ea"/>
+          <a:cs typeface="+mn-cs"/>
+        </a:defRPr>
+      </a:lvl8pPr>
+      <a:lvl9pPr marL="3886200" indent="-228600" algn="l" defTabSz="914400" rtl="0" eaLnBrk="1" latinLnBrk="0" hangingPunct="1">
+        <a:lnSpc>
+          <a:spcPct val="90000"/>
+        </a:lnSpc>
+        <a:spcBef>
+          <a:spcPts val="500"/>
+        </a:spcBef>
+        <a:buFont typeface="Arial" panose="020B0604020202020204" pitchFamily="34" charset="0"/>
+        <a:buChar char="•"/>
+        <a:defRPr sz="1800" kern="1200">
+          <a:solidFill>
+            <a:schemeClr val="tx1"/>
+          </a:solidFill>
+          <a:latin typeface="+mn-lt"/>
+          <a:ea typeface="+mn-ea"/>
+          <a:cs typeface="+mn-cs"/>
+        </a:defRPr>
+      </a:lvl9pPr>
+    </p:bodyStyle>
+    <p:otherStyle>
+      <a:defPPr>
+        <a:defRPr lang="en-SE"/>
+      </a:defPPr>
+      <a:lvl1pPr marL="0" algn="l" defTabSz="914400" rtl="0" eaLnBrk="1" latinLnBrk="0" hangingPunct="1">
+        <a:defRPr sz="1800" kern="1200">
+          <a:solidFill>
+            <a:schemeClr val="tx1"/>
+          </a:solidFill>
+          <a:latin typeface="+mn-lt"/>
+          <a:ea typeface="+mn-ea"/>
+          <a:cs typeface="+mn-cs"/>
+        </a:defRPr>
+      </a:lvl1pPr>
+      <a:lvl2pPr marL="457200" algn="l" defTabSz="914400" rtl="0" eaLnBrk="1" latinLnBrk="0" hangingPunct="1">
+        <a:defRPr sz="1800" kern="1200">
+          <a:solidFill>
+            <a:schemeClr val="tx1"/>
+          </a:solidFill>
+          <a:latin typeface="+mn-lt"/>
+          <a:ea typeface="+mn-ea"/>
+          <a:cs typeface="+mn-cs"/>
+        </a:defRPr>
+      </a:lvl2pPr>
+      <a:lvl3pPr marL="914400" algn="l" defTabSz="914400" rtl="0" eaLnBrk="1" latinLnBrk="0" hangingPunct="1">
+        <a:defRPr sz="1800" kern="1200">
+          <a:solidFill>
+            <a:schemeClr val="tx1"/>
+          </a:solidFill>
+          <a:latin typeface="+mn-lt"/>
+          <a:ea typeface="+mn-ea"/>
+          <a:cs typeface="+mn-cs"/>
+        </a:defRPr>
+      </a:lvl3pPr>
+      <a:lvl4pPr marL="1371600" algn="l" defTabSz="914400" rtl="0" eaLnBrk="1" latinLnBrk="0" hangingPunct="1">
+        <a:defRPr sz="1800" kern="1200">
+          <a:solidFill>
+            <a:schemeClr val="tx1"/>
+          </a:solidFill>
+          <a:latin typeface="+mn-lt"/>
+          <a:ea typeface="+mn-ea"/>
+          <a:cs typeface="+mn-cs"/>
+        </a:defRPr>
+      </a:lvl4pPr>
+      <a:lvl5pPr marL="1828800" algn="l" defTabSz="914400" rtl="0" eaLnBrk="1" latinLnBrk="0" hangingPunct="1">
+        <a:defRPr sz="1800" kern="1200">
+          <a:solidFill>
+            <a:schemeClr val="tx1"/>
+          </a:solidFill>
+          <a:latin typeface="+mn-lt"/>
+          <a:ea typeface="+mn-ea"/>
+          <a:cs typeface="+mn-cs"/>
+        </a:defRPr>
+      </a:lvl5pPr>
+      <a:lvl6pPr marL="2286000" algn="l" defTabSz="914400" rtl="0" eaLnBrk="1" latinLnBrk="0" hangingPunct="1">
+        <a:defRPr sz="1800" kern="1200">
+          <a:solidFill>
+            <a:schemeClr val="tx1"/>
+          </a:solidFill>
+          <a:latin typeface="+mn-lt"/>
+          <a:ea typeface="+mn-ea"/>
+          <a:cs typeface="+mn-cs"/>
+        </a:defRPr>
+      </a:lvl6pPr>
+      <a:lvl7pPr marL="2743200" algn="l" defTabSz="914400" rtl="0" eaLnBrk="1" latinLnBrk="0" hangingPunct="1">
+        <a:defRPr sz="1800" kern="1200">
+          <a:solidFill>
+            <a:schemeClr val="tx1"/>
+          </a:solidFill>
+          <a:latin typeface="+mn-lt"/>
+          <a:ea typeface="+mn-ea"/>
+          <a:cs typeface="+mn-cs"/>
+        </a:defRPr>
+      </a:lvl7pPr>
+      <a:lvl8pPr marL="3200400" algn="l" defTabSz="914400" rtl="0" eaLnBrk="1" latinLnBrk="0" hangingPunct="1">
+        <a:defRPr sz="1800" kern="1200">
+          <a:solidFill>
+            <a:schemeClr val="tx1"/>
+          </a:solidFill>
+          <a:latin typeface="+mn-lt"/>
+          <a:ea typeface="+mn-ea"/>
+          <a:cs typeface="+mn-cs"/>
+        </a:defRPr>
+      </a:lvl8pPr>
+      <a:lvl9pPr marL="3657600" algn="l" defTabSz="914400" rtl="0" eaLnBrk="1" latinLnBrk="0" hangingPunct="1">
+        <a:defRPr sz="1800" kern="1200">
+          <a:solidFill>
+            <a:schemeClr val="tx1"/>
+          </a:solidFill>
+          <a:latin typeface="+mn-lt"/>
+          <a:ea typeface="+mn-ea"/>
+          <a:cs typeface="+mn-cs"/>
+        </a:defRPr>
+      </a:lvl9pPr>
+    </p:otherStyle>
+  </p:txStyles>
 </p:sldMaster>
 </file>
 
 <file path=ppt/slides/slide1.xml><?xml version="1.0" encoding="utf-8"?>
-<p:sld xmlns:a="http://schemas.openxmlformats.org/drawingml/2006/main" xmlns:p="http://schemas.openxmlformats.org/presentationml/2006/main" xmlns:r="http://schemas.openxmlformats.org/officeDocument/2006/relationships" xmlns:p14="http://schemas.microsoft.com/office/powerpoint/2010/main" xmlns:p15="http://schemas.microsoft.com/office/powerpoint/2012/main" xmlns:mc="http://schemas.openxmlformats.org/markup-compatibility/2006">
+<p:sld xmlns:a="http://schemas.openxmlformats.org/drawingml/2006/main" xmlns:r="http://schemas.openxmlformats.org/officeDocument/2006/relationships" xmlns:p="http://schemas.openxmlformats.org/presentationml/2006/main">
   <p:cSld>
     <p:bg>
       <p:bgPr>
         <a:solidFill>
           <a:srgbClr val="FFFFFF"/>
         </a:solidFill>
+        <a:effectLst/>
       </p:bgPr>
     </p:bg>
     <p:spTree>
@@ -4022,7 +4464,7 @@
           <p:nvPr/>
         </p:nvPicPr>
         <p:blipFill>
-          <a:blip r:embed="rId1"/>
+          <a:blip r:embed="rId3"/>
           <a:stretch/>
         </p:blipFill>
         <p:spPr>
@@ -4046,7 +4488,7 @@
           <p:nvPr/>
         </p:nvPicPr>
         <p:blipFill>
-          <a:blip r:embed="rId2"/>
+          <a:blip r:embed="rId4"/>
           <a:stretch/>
         </p:blipFill>
         <p:spPr>
@@ -4070,7 +4512,7 @@
           <p:nvPr/>
         </p:nvPicPr>
         <p:blipFill>
-          <a:blip r:embed="rId3"/>
+          <a:blip r:embed="rId5"/>
           <a:stretch/>
         </p:blipFill>
         <p:spPr>
@@ -4094,7 +4536,7 @@
           <p:nvPr/>
         </p:nvPicPr>
         <p:blipFill>
-          <a:blip r:embed="rId4"/>
+          <a:blip r:embed="rId6"/>
           <a:stretch/>
         </p:blipFill>
         <p:spPr>
@@ -4131,15 +4573,22 @@
           </a:ln>
         </p:spPr>
         <p:style>
-          <a:lnRef idx="0"/>
-          <a:fillRef idx="0"/>
-          <a:effectRef idx="0"/>
+          <a:lnRef idx="0">
+            <a:scrgbClr r="0" g="0" b="0"/>
+          </a:lnRef>
+          <a:fillRef idx="0">
+            <a:scrgbClr r="0" g="0" b="0"/>
+          </a:fillRef>
+          <a:effectRef idx="0">
+            <a:scrgbClr r="0" g="0" b="0"/>
+          </a:effectRef>
           <a:fontRef idx="minor"/>
         </p:style>
         <p:txBody>
           <a:bodyPr lIns="0" tIns="0" rIns="0" bIns="0" anchor="ctr">
             <a:noAutofit/>
           </a:bodyPr>
+          <a:lstStyle/>
           <a:p>
             <a:pPr algn="ctr" defTabSz="914400">
               <a:lnSpc>
@@ -4159,55 +4608,7 @@
                 <a:latin typeface="Cambria"/>
                 <a:ea typeface="Cambria"/>
               </a:rPr>
-              <a:t>Introduction to </a:t>
-            </a:r>
-            <a:r>
-              <a:rPr lang="en-US" sz="3200" b="1" u="none" strike="noStrike">
-                <a:solidFill>
-                  <a:srgbClr val="1E3A5F"/>
-                </a:solidFill>
-                <a:effectLst/>
-                <a:uFillTx/>
-                <a:latin typeface="Cambria"/>
-                <a:ea typeface="Cambria"/>
-              </a:rPr>
-              <a:t>Causal </a:t>
-            </a:r>
-            <a:r>
-              <a:rPr lang="en-US" sz="3200" b="1" u="none" strike="noStrike">
-                <a:solidFill>
-                  <a:srgbClr val="1E3A5F"/>
-                </a:solidFill>
-                <a:effectLst/>
-                <a:uFillTx/>
-                <a:latin typeface="Cambria"/>
-                <a:ea typeface="Cambria"/>
-              </a:rPr>
-              <a:t>Inference for </a:t>
-            </a:r>
-            <a:r>
-              <a:rPr lang="en-US" sz="3200" b="1" u="none" strike="noStrike">
-                <a:solidFill>
-                  <a:srgbClr val="1E3A5F"/>
-                </a:solidFill>
-                <a:effectLst/>
-                <a:uFillTx/>
-                <a:latin typeface="Cambria"/>
-                <a:ea typeface="Cambria"/>
-              </a:rPr>
-              <a:t>Software </a:t>
-            </a:r>
-            <a:r>
-              <a:rPr lang="en-US" sz="3200" b="1" u="none" strike="noStrike">
-                <a:solidFill>
-                  <a:srgbClr val="1E3A5F"/>
-                </a:solidFill>
-                <a:effectLst/>
-                <a:uFillTx/>
-                <a:latin typeface="Cambria"/>
-                <a:ea typeface="Cambria"/>
-              </a:rPr>
-              <a:t>Engineering</a:t>
+              <a:t>Introduction to Causal Inference for Software Engineering</a:t>
             </a:r>
             <a:endParaRPr lang="en-GB" sz="3200" b="0" u="none" strike="noStrike">
               <a:solidFill>
@@ -4240,15 +4641,22 @@
           </a:ln>
         </p:spPr>
         <p:style>
-          <a:lnRef idx="0"/>
-          <a:fillRef idx="0"/>
-          <a:effectRef idx="0"/>
+          <a:lnRef idx="0">
+            <a:scrgbClr r="0" g="0" b="0"/>
+          </a:lnRef>
+          <a:fillRef idx="0">
+            <a:scrgbClr r="0" g="0" b="0"/>
+          </a:fillRef>
+          <a:effectRef idx="0">
+            <a:scrgbClr r="0" g="0" b="0"/>
+          </a:effectRef>
           <a:fontRef idx="minor"/>
         </p:style>
         <p:txBody>
           <a:bodyPr lIns="0" tIns="0" rIns="0" bIns="0" anchor="ctr">
             <a:noAutofit/>
           </a:bodyPr>
+          <a:lstStyle/>
           <a:p>
             <a:pPr algn="ctr" defTabSz="914400">
               <a:lnSpc>
@@ -4301,15 +4709,22 @@
           </a:ln>
         </p:spPr>
         <p:style>
-          <a:lnRef idx="0"/>
-          <a:fillRef idx="0"/>
-          <a:effectRef idx="0"/>
+          <a:lnRef idx="0">
+            <a:scrgbClr r="0" g="0" b="0"/>
+          </a:lnRef>
+          <a:fillRef idx="0">
+            <a:scrgbClr r="0" g="0" b="0"/>
+          </a:fillRef>
+          <a:effectRef idx="0">
+            <a:scrgbClr r="0" g="0" b="0"/>
+          </a:effectRef>
           <a:fontRef idx="minor"/>
         </p:style>
         <p:txBody>
           <a:bodyPr lIns="0" tIns="0" rIns="0" bIns="0" anchor="ctr">
             <a:noAutofit/>
           </a:bodyPr>
+          <a:lstStyle/>
           <a:p>
             <a:pPr algn="ctr" defTabSz="914400">
               <a:lnSpc>
@@ -4362,15 +4777,22 @@
           </a:ln>
         </p:spPr>
         <p:style>
-          <a:lnRef idx="0"/>
-          <a:fillRef idx="0"/>
-          <a:effectRef idx="0"/>
+          <a:lnRef idx="0">
+            <a:scrgbClr r="0" g="0" b="0"/>
+          </a:lnRef>
+          <a:fillRef idx="0">
+            <a:scrgbClr r="0" g="0" b="0"/>
+          </a:fillRef>
+          <a:effectRef idx="0">
+            <a:scrgbClr r="0" g="0" b="0"/>
+          </a:effectRef>
           <a:fontRef idx="minor"/>
         </p:style>
         <p:txBody>
           <a:bodyPr lIns="0" tIns="0" rIns="0" bIns="0" anchor="ctr">
             <a:noAutofit/>
           </a:bodyPr>
+          <a:lstStyle/>
           <a:p>
             <a:endParaRPr lang="en-US" sz="900" b="0" u="none" strike="noStrike">
               <a:solidFill>
@@ -4385,25 +4807,21 @@
       </p:sp>
     </p:spTree>
   </p:cSld>
-  <mc:AlternateContent>
-    <mc:Choice Requires="p14">
-      <p:transition spd="slow" p14:dur="2000"/>
-    </mc:Choice>
-    <mc:Fallback>
-      <p:transition spd="slow"/>
-    </mc:Fallback>
-  </mc:AlternateContent>
+  <p:clrMapOvr>
+    <a:masterClrMapping/>
+  </p:clrMapOvr>
 </p:sld>
 </file>
 
 <file path=ppt/slides/slide2.xml><?xml version="1.0" encoding="utf-8"?>
-<p:sld xmlns:a="http://schemas.openxmlformats.org/drawingml/2006/main" xmlns:p="http://schemas.openxmlformats.org/presentationml/2006/main" xmlns:r="http://schemas.openxmlformats.org/officeDocument/2006/relationships" xmlns:p14="http://schemas.microsoft.com/office/powerpoint/2010/main" xmlns:p15="http://schemas.microsoft.com/office/powerpoint/2012/main" xmlns:mc="http://schemas.openxmlformats.org/markup-compatibility/2006">
+<p:sld xmlns:a="http://schemas.openxmlformats.org/drawingml/2006/main" xmlns:r="http://schemas.openxmlformats.org/officeDocument/2006/relationships" xmlns:p="http://schemas.openxmlformats.org/presentationml/2006/main">
   <p:cSld>
     <p:bg>
       <p:bgPr>
         <a:solidFill>
           <a:srgbClr val="FFFFFF"/>
         </a:solidFill>
+        <a:effectLst/>
       </p:bgPr>
     </p:bg>
     <p:spTree>
@@ -4427,7 +4845,7 @@
           <p:nvPr/>
         </p:nvPicPr>
         <p:blipFill>
-          <a:blip r:embed="rId1"/>
+          <a:blip r:embed="rId3"/>
           <a:stretch/>
         </p:blipFill>
         <p:spPr>
@@ -4451,7 +4869,7 @@
           <p:nvPr/>
         </p:nvPicPr>
         <p:blipFill>
-          <a:blip r:embed="rId2"/>
+          <a:blip r:embed="rId4"/>
           <a:stretch/>
         </p:blipFill>
         <p:spPr>
@@ -4475,7 +4893,7 @@
           <p:nvPr/>
         </p:nvPicPr>
         <p:blipFill>
-          <a:blip r:embed="rId3"/>
+          <a:blip r:embed="rId5"/>
           <a:stretch/>
         </p:blipFill>
         <p:spPr>
@@ -4499,7 +4917,7 @@
           <p:nvPr/>
         </p:nvPicPr>
         <p:blipFill>
-          <a:blip r:embed="rId4"/>
+          <a:blip r:embed="rId6"/>
           <a:stretch/>
         </p:blipFill>
         <p:spPr>
@@ -4536,15 +4954,22 @@
           </a:ln>
         </p:spPr>
         <p:style>
-          <a:lnRef idx="0"/>
-          <a:fillRef idx="0"/>
-          <a:effectRef idx="0"/>
+          <a:lnRef idx="0">
+            <a:scrgbClr r="0" g="0" b="0"/>
+          </a:lnRef>
+          <a:fillRef idx="0">
+            <a:scrgbClr r="0" g="0" b="0"/>
+          </a:fillRef>
+          <a:effectRef idx="0">
+            <a:scrgbClr r="0" g="0" b="0"/>
+          </a:effectRef>
           <a:fontRef idx="minor"/>
         </p:style>
         <p:txBody>
           <a:bodyPr lIns="0" tIns="0" rIns="0" bIns="0" anchor="ctr">
             <a:noAutofit/>
           </a:bodyPr>
+          <a:lstStyle/>
           <a:p>
             <a:pPr algn="ctr" defTabSz="914400">
               <a:lnSpc>
@@ -4555,7 +4980,7 @@
               </a:tabLst>
             </a:pPr>
             <a:r>
-              <a:rPr lang="en-US" sz="1400" b="0" u="none" spc="201" strike="noStrike">
+              <a:rPr lang="en-US" sz="1400" b="0" u="none" strike="noStrike" spc="201">
                 <a:solidFill>
                   <a:srgbClr val="7A8794"/>
                 </a:solidFill>
@@ -4597,15 +5022,22 @@
           </a:ln>
         </p:spPr>
         <p:style>
-          <a:lnRef idx="0"/>
-          <a:fillRef idx="0"/>
-          <a:effectRef idx="0"/>
+          <a:lnRef idx="0">
+            <a:scrgbClr r="0" g="0" b="0"/>
+          </a:lnRef>
+          <a:fillRef idx="0">
+            <a:scrgbClr r="0" g="0" b="0"/>
+          </a:fillRef>
+          <a:effectRef idx="0">
+            <a:scrgbClr r="0" g="0" b="0"/>
+          </a:effectRef>
           <a:fontRef idx="minor"/>
         </p:style>
         <p:txBody>
           <a:bodyPr lIns="0" tIns="0" rIns="0" bIns="0" anchor="ctr">
             <a:noAutofit/>
           </a:bodyPr>
+          <a:lstStyle/>
           <a:p>
             <a:pPr algn="ctr" defTabSz="914400">
               <a:lnSpc>
@@ -4658,15 +5090,22 @@
           </a:ln>
         </p:spPr>
         <p:style>
-          <a:lnRef idx="0"/>
-          <a:fillRef idx="0"/>
-          <a:effectRef idx="0"/>
+          <a:lnRef idx="0">
+            <a:scrgbClr r="0" g="0" b="0"/>
+          </a:lnRef>
+          <a:fillRef idx="0">
+            <a:scrgbClr r="0" g="0" b="0"/>
+          </a:fillRef>
+          <a:effectRef idx="0">
+            <a:scrgbClr r="0" g="0" b="0"/>
+          </a:effectRef>
           <a:fontRef idx="minor"/>
         </p:style>
         <p:txBody>
           <a:bodyPr lIns="0" tIns="0" rIns="0" bIns="0" anchor="ctr">
             <a:noAutofit/>
           </a:bodyPr>
+          <a:lstStyle/>
           <a:p>
             <a:pPr algn="ctr" defTabSz="914400">
               <a:lnSpc>
@@ -4719,15 +5158,22 @@
           </a:ln>
         </p:spPr>
         <p:style>
-          <a:lnRef idx="0"/>
-          <a:fillRef idx="0"/>
-          <a:effectRef idx="0"/>
+          <a:lnRef idx="0">
+            <a:scrgbClr r="0" g="0" b="0"/>
+          </a:lnRef>
+          <a:fillRef idx="0">
+            <a:scrgbClr r="0" g="0" b="0"/>
+          </a:fillRef>
+          <a:effectRef idx="0">
+            <a:scrgbClr r="0" g="0" b="0"/>
+          </a:effectRef>
           <a:fontRef idx="minor"/>
         </p:style>
         <p:txBody>
           <a:bodyPr lIns="90000" tIns="45000" rIns="90000" bIns="45000" anchor="t">
             <a:noAutofit/>
           </a:bodyPr>
+          <a:lstStyle/>
           <a:p>
             <a:pPr algn="r" defTabSz="914400">
               <a:lnSpc>
@@ -4744,7 +5190,7 @@
                 <a:latin typeface="Calibri"/>
                 <a:ea typeface="Calibri"/>
               </a:rPr>
-              <a:t>&lt;number&gt;</a:t>
+              <a:t>2</a:t>
             </a:fld>
             <a:endParaRPr lang="en-GB" sz="900" b="0" u="none" strike="noStrike">
               <a:solidFill>
@@ -4759,19 +5205,14 @@
       </p:sp>
     </p:spTree>
   </p:cSld>
-  <mc:AlternateContent>
-    <mc:Choice Requires="p14">
-      <p:transition spd="slow" p14:dur="2000"/>
-    </mc:Choice>
-    <mc:Fallback>
-      <p:transition spd="slow"/>
-    </mc:Fallback>
-  </mc:AlternateContent>
+  <p:clrMapOvr>
+    <a:masterClrMapping/>
+  </p:clrMapOvr>
 </p:sld>
 </file>
 
 <file path=ppt/slides/slide3.xml><?xml version="1.0" encoding="utf-8"?>
-<p:sld xmlns:a="http://schemas.openxmlformats.org/drawingml/2006/main" xmlns:p="http://schemas.openxmlformats.org/presentationml/2006/main" xmlns:r="http://schemas.openxmlformats.org/officeDocument/2006/relationships" xmlns:p14="http://schemas.microsoft.com/office/powerpoint/2010/main" xmlns:p15="http://schemas.microsoft.com/office/powerpoint/2012/main" xmlns:mc="http://schemas.openxmlformats.org/markup-compatibility/2006">
+<p:sld xmlns:a="http://schemas.openxmlformats.org/drawingml/2006/main" xmlns:r="http://schemas.openxmlformats.org/officeDocument/2006/relationships" xmlns:p="http://schemas.openxmlformats.org/presentationml/2006/main">
   <p:cSld>
     <p:spTree>
       <p:nvGrpSpPr>
@@ -4814,6 +5255,7 @@
           <a:bodyPr lIns="91440" tIns="45720" rIns="91440" bIns="45720" anchor="ctr">
             <a:noAutofit/>
           </a:bodyPr>
+          <a:lstStyle/>
           <a:p>
             <a:pPr indent="0" algn="l" defTabSz="914400">
               <a:lnSpc>
@@ -4831,55 +5273,7 @@
                 <a:latin typeface="Cambria"/>
                 <a:ea typeface="Cambria"/>
               </a:rPr>
-              <a:t>What is </a:t>
-            </a:r>
-            <a:r>
-              <a:rPr lang="en-GB" sz="2600" b="1" u="none" strike="noStrike">
-                <a:solidFill>
-                  <a:srgbClr val="1E3A5F"/>
-                </a:solidFill>
-                <a:effectLst/>
-                <a:uFillTx/>
-                <a:latin typeface="Cambria"/>
-                <a:ea typeface="Cambria"/>
-              </a:rPr>
-              <a:t>the goal </a:t>
-            </a:r>
-            <a:r>
-              <a:rPr lang="en-GB" sz="2600" b="1" u="none" strike="noStrike">
-                <a:solidFill>
-                  <a:srgbClr val="1E3A5F"/>
-                </a:solidFill>
-                <a:effectLst/>
-                <a:uFillTx/>
-                <a:latin typeface="Cambria"/>
-                <a:ea typeface="Cambria"/>
-              </a:rPr>
-              <a:t>of </a:t>
-            </a:r>
-            <a:r>
-              <a:rPr lang="en-GB" sz="2600" b="1" u="none" strike="noStrike">
-                <a:solidFill>
-                  <a:srgbClr val="1E3A5F"/>
-                </a:solidFill>
-                <a:effectLst/>
-                <a:uFillTx/>
-                <a:latin typeface="Cambria"/>
-                <a:ea typeface="Cambria"/>
-              </a:rPr>
-              <a:t>estimatio</a:t>
-            </a:r>
-            <a:r>
-              <a:rPr lang="en-GB" sz="2600" b="1" u="none" strike="noStrike">
-                <a:solidFill>
-                  <a:srgbClr val="1E3A5F"/>
-                </a:solidFill>
-                <a:effectLst/>
-                <a:uFillTx/>
-                <a:latin typeface="Cambria"/>
-                <a:ea typeface="Cambria"/>
-              </a:rPr>
-              <a:t>n?</a:t>
+              <a:t>What is the goal of estimation?</a:t>
             </a:r>
             <a:endParaRPr lang="en-GB" sz="2600" b="1" u="none" strike="noStrike">
               <a:solidFill>
@@ -4953,7 +5347,7 @@
                 <a:latin typeface="Calibri"/>
                 <a:ea typeface="Calibri"/>
               </a:rPr>
-              <a:t>&lt;number&gt;</a:t>
+              <a:t>3</a:t>
             </a:fld>
             <a:endParaRPr lang="en-GB" sz="900" b="0" u="none" strike="noStrike">
               <a:solidFill>
@@ -4974,24 +5368,47 @@
         </p:nvGraphicFramePr>
         <p:xfrm>
           <a:off x="490680" y="2221560"/>
-          <a:ext cx="8194320" cy="2484000"/>
+          <a:ext cx="8193600" cy="2482560"/>
         </p:xfrm>
         <a:graphic>
           <a:graphicData uri="http://schemas.openxmlformats.org/drawingml/2006/table">
             <a:tbl>
               <a:tblPr/>
               <a:tblGrid>
-                <a:gridCol w="1519200"/>
-                <a:gridCol w="2512440"/>
-                <a:gridCol w="2079360"/>
-                <a:gridCol w="2082600"/>
+                <a:gridCol w="1519200">
+                  <a:extLst>
+                    <a:ext uri="{9D8B030D-6E8A-4147-A177-3AD203B41FA5}">
+                      <a16:colId xmlns:a16="http://schemas.microsoft.com/office/drawing/2014/main" val="20000"/>
+                    </a:ext>
+                  </a:extLst>
+                </a:gridCol>
+                <a:gridCol w="2512440">
+                  <a:extLst>
+                    <a:ext uri="{9D8B030D-6E8A-4147-A177-3AD203B41FA5}">
+                      <a16:colId xmlns:a16="http://schemas.microsoft.com/office/drawing/2014/main" val="20001"/>
+                    </a:ext>
+                  </a:extLst>
+                </a:gridCol>
+                <a:gridCol w="2079360">
+                  <a:extLst>
+                    <a:ext uri="{9D8B030D-6E8A-4147-A177-3AD203B41FA5}">
+                      <a16:colId xmlns:a16="http://schemas.microsoft.com/office/drawing/2014/main" val="20002"/>
+                    </a:ext>
+                  </a:extLst>
+                </a:gridCol>
+                <a:gridCol w="2082600">
+                  <a:extLst>
+                    <a:ext uri="{9D8B030D-6E8A-4147-A177-3AD203B41FA5}">
+                      <a16:colId xmlns:a16="http://schemas.microsoft.com/office/drawing/2014/main" val="20003"/>
+                    </a:ext>
+                  </a:extLst>
+                </a:gridCol>
               </a:tblGrid>
               <a:tr h="219960">
                 <a:tc>
                   <a:txBody>
-                    <a:bodyPr lIns="36000" tIns="36000" rIns="36000" bIns="36000" anchor="t">
-                      <a:noAutofit/>
-                    </a:bodyPr>
+                    <a:bodyPr/>
+                    <a:lstStyle/>
                     <a:p>
                       <a:pPr defTabSz="914400">
                         <a:lnSpc>
@@ -5020,7 +5437,7 @@
                       </a:endParaRPr>
                     </a:p>
                   </a:txBody>
-                  <a:tcPr anchor="t" marL="36000" marR="36000" marT="36000" marB="36000">
+                  <a:tcPr marL="36000" marR="36000" marT="36000" marB="36000">
                     <a:lnL w="7200">
                       <a:solidFill>
                         <a:srgbClr val="000000"/>
@@ -5050,9 +5467,8 @@
                 </a:tc>
                 <a:tc>
                   <a:txBody>
-                    <a:bodyPr lIns="36000" tIns="36000" rIns="36000" bIns="36000" anchor="t">
-                      <a:noAutofit/>
-                    </a:bodyPr>
+                    <a:bodyPr/>
+                    <a:lstStyle/>
                     <a:p>
                       <a:pPr defTabSz="914400">
                         <a:lnSpc>
@@ -5081,7 +5497,7 @@
                       </a:endParaRPr>
                     </a:p>
                   </a:txBody>
-                  <a:tcPr anchor="t" marL="36000" marR="36000" marT="36000" marB="36000">
+                  <a:tcPr marL="36000" marR="36000" marT="36000" marB="36000">
                     <a:lnL w="7200">
                       <a:solidFill>
                         <a:srgbClr val="000000"/>
@@ -5111,9 +5527,8 @@
                 </a:tc>
                 <a:tc>
                   <a:txBody>
-                    <a:bodyPr lIns="36000" tIns="36000" rIns="36000" bIns="36000" anchor="t">
-                      <a:noAutofit/>
-                    </a:bodyPr>
+                    <a:bodyPr/>
+                    <a:lstStyle/>
                     <a:p>
                       <a:pPr defTabSz="914400">
                         <a:lnSpc>
@@ -5142,7 +5557,7 @@
                       </a:endParaRPr>
                     </a:p>
                   </a:txBody>
-                  <a:tcPr anchor="t" marL="36000" marR="36000" marT="36000" marB="36000">
+                  <a:tcPr marL="36000" marR="36000" marT="36000" marB="36000">
                     <a:lnL w="7200">
                       <a:solidFill>
                         <a:srgbClr val="000000"/>
@@ -5172,9 +5587,8 @@
                 </a:tc>
                 <a:tc>
                   <a:txBody>
-                    <a:bodyPr lIns="36000" tIns="36000" rIns="36000" bIns="36000" anchor="t">
-                      <a:noAutofit/>
-                    </a:bodyPr>
+                    <a:bodyPr/>
+                    <a:lstStyle/>
                     <a:p>
                       <a:pPr defTabSz="914400">
                         <a:lnSpc>
@@ -5203,7 +5617,7 @@
                       </a:endParaRPr>
                     </a:p>
                   </a:txBody>
-                  <a:tcPr anchor="t" marL="36000" marR="36000" marT="36000" marB="36000">
+                  <a:tcPr marL="36000" marR="36000" marT="36000" marB="36000">
                     <a:lnL w="7200">
                       <a:solidFill>
                         <a:srgbClr val="000000"/>
@@ -5231,13 +5645,17 @@
                     <a:noFill/>
                   </a:tcPr>
                 </a:tc>
+                <a:extLst>
+                  <a:ext uri="{0D108BD9-81ED-4DB2-BD59-A6C34878D82A}">
+                    <a16:rowId xmlns:a16="http://schemas.microsoft.com/office/drawing/2014/main" val="10000"/>
+                  </a:ext>
+                </a:extLst>
               </a:tr>
               <a:tr h="780480">
                 <a:tc>
                   <a:txBody>
-                    <a:bodyPr lIns="36000" tIns="36000" rIns="36000" bIns="36000" anchor="t">
-                      <a:noAutofit/>
-                    </a:bodyPr>
+                    <a:bodyPr/>
+                    <a:lstStyle/>
                     <a:p>
                       <a:pPr defTabSz="914400">
                         <a:lnSpc>
@@ -5266,7 +5684,7 @@
                       </a:endParaRPr>
                     </a:p>
                   </a:txBody>
-                  <a:tcPr anchor="t" marL="36000" marR="36000" marT="36000" marB="36000">
+                  <a:tcPr marL="36000" marR="36000" marT="36000" marB="36000">
                     <a:lnL w="7200">
                       <a:solidFill>
                         <a:srgbClr val="000000"/>
@@ -5296,9 +5714,8 @@
                 </a:tc>
                 <a:tc>
                   <a:txBody>
-                    <a:bodyPr lIns="36000" tIns="36000" rIns="36000" bIns="36000" anchor="t">
-                      <a:noAutofit/>
-                    </a:bodyPr>
+                    <a:bodyPr/>
+                    <a:lstStyle/>
                     <a:p>
                       <a:pPr defTabSz="914400">
                         <a:lnSpc>
@@ -5327,7 +5744,7 @@
                       </a:endParaRPr>
                     </a:p>
                   </a:txBody>
-                  <a:tcPr anchor="t" marL="36000" marR="36000" marT="36000" marB="36000">
+                  <a:tcPr marL="36000" marR="36000" marT="36000" marB="36000">
                     <a:lnL w="7200">
                       <a:solidFill>
                         <a:srgbClr val="000000"/>
@@ -5357,9 +5774,8 @@
                 </a:tc>
                 <a:tc>
                   <a:txBody>
-                    <a:bodyPr lIns="36000" tIns="36000" rIns="36000" bIns="36000" anchor="t">
-                      <a:noAutofit/>
-                    </a:bodyPr>
+                    <a:bodyPr/>
+                    <a:lstStyle/>
                     <a:p>
                       <a:pPr defTabSz="914400">
                         <a:lnSpc>
@@ -5388,7 +5804,7 @@
                       </a:endParaRPr>
                     </a:p>
                   </a:txBody>
-                  <a:tcPr anchor="t" marL="36000" marR="36000" marT="36000" marB="36000">
+                  <a:tcPr marL="36000" marR="36000" marT="36000" marB="36000">
                     <a:lnL w="7200">
                       <a:solidFill>
                         <a:srgbClr val="000000"/>
@@ -5418,9 +5834,8 @@
                 </a:tc>
                 <a:tc>
                   <a:txBody>
-                    <a:bodyPr lIns="36000" tIns="36000" rIns="36000" bIns="36000" anchor="t">
-                      <a:noAutofit/>
-                    </a:bodyPr>
+                    <a:bodyPr/>
+                    <a:lstStyle/>
                     <a:p>
                       <a:pPr defTabSz="914400">
                         <a:lnSpc>
@@ -5449,7 +5864,7 @@
                       </a:endParaRPr>
                     </a:p>
                   </a:txBody>
-                  <a:tcPr anchor="t" marL="36000" marR="36000" marT="36000" marB="36000">
+                  <a:tcPr marL="36000" marR="36000" marT="36000" marB="36000">
                     <a:lnL w="7200">
                       <a:solidFill>
                         <a:srgbClr val="000000"/>
@@ -5477,13 +5892,17 @@
                     <a:noFill/>
                   </a:tcPr>
                 </a:tc>
+                <a:extLst>
+                  <a:ext uri="{0D108BD9-81ED-4DB2-BD59-A6C34878D82A}">
+                    <a16:rowId xmlns:a16="http://schemas.microsoft.com/office/drawing/2014/main" val="10001"/>
+                  </a:ext>
+                </a:extLst>
               </a:tr>
               <a:tr h="780480">
                 <a:tc>
                   <a:txBody>
-                    <a:bodyPr lIns="36000" tIns="36000" rIns="36000" bIns="36000" anchor="t">
-                      <a:noAutofit/>
-                    </a:bodyPr>
+                    <a:bodyPr/>
+                    <a:lstStyle/>
                     <a:p>
                       <a:pPr defTabSz="914400">
                         <a:lnSpc>
@@ -5512,7 +5931,7 @@
                       </a:endParaRPr>
                     </a:p>
                   </a:txBody>
-                  <a:tcPr anchor="t" marL="36000" marR="36000" marT="36000" marB="36000">
+                  <a:tcPr marL="36000" marR="36000" marT="36000" marB="36000">
                     <a:lnL w="7200">
                       <a:solidFill>
                         <a:srgbClr val="000000"/>
@@ -5542,9 +5961,8 @@
                 </a:tc>
                 <a:tc>
                   <a:txBody>
-                    <a:bodyPr lIns="36000" tIns="36000" rIns="36000" bIns="36000" anchor="t">
-                      <a:noAutofit/>
-                    </a:bodyPr>
+                    <a:bodyPr/>
+                    <a:lstStyle/>
                     <a:p>
                       <a:pPr defTabSz="914400">
                         <a:lnSpc>
@@ -5573,7 +5991,7 @@
                       </a:endParaRPr>
                     </a:p>
                   </a:txBody>
-                  <a:tcPr anchor="t" marL="36000" marR="36000" marT="36000" marB="36000">
+                  <a:tcPr marL="36000" marR="36000" marT="36000" marB="36000">
                     <a:lnL w="7200">
                       <a:solidFill>
                         <a:srgbClr val="000000"/>
@@ -5603,9 +6021,8 @@
                 </a:tc>
                 <a:tc>
                   <a:txBody>
-                    <a:bodyPr lIns="36000" tIns="36000" rIns="36000" bIns="36000" anchor="t">
-                      <a:noAutofit/>
-                    </a:bodyPr>
+                    <a:bodyPr/>
+                    <a:lstStyle/>
                     <a:p>
                       <a:pPr defTabSz="914400">
                         <a:lnSpc>
@@ -5634,7 +6051,7 @@
                       </a:endParaRPr>
                     </a:p>
                   </a:txBody>
-                  <a:tcPr anchor="t" marL="36000" marR="36000" marT="36000" marB="36000">
+                  <a:tcPr marL="36000" marR="36000" marT="36000" marB="36000">
                     <a:lnL w="7200">
                       <a:solidFill>
                         <a:srgbClr val="000000"/>
@@ -5664,9 +6081,8 @@
                 </a:tc>
                 <a:tc>
                   <a:txBody>
-                    <a:bodyPr lIns="36000" tIns="36000" rIns="36000" bIns="36000" anchor="t">
-                      <a:noAutofit/>
-                    </a:bodyPr>
+                    <a:bodyPr/>
+                    <a:lstStyle/>
                     <a:p>
                       <a:pPr defTabSz="914400">
                         <a:lnSpc>
@@ -5695,7 +6111,7 @@
                       </a:endParaRPr>
                     </a:p>
                   </a:txBody>
-                  <a:tcPr anchor="t" marL="36000" marR="36000" marT="36000" marB="36000">
+                  <a:tcPr marL="36000" marR="36000" marT="36000" marB="36000">
                     <a:lnL w="7200">
                       <a:solidFill>
                         <a:srgbClr val="000000"/>
@@ -5723,13 +6139,17 @@
                     <a:noFill/>
                   </a:tcPr>
                 </a:tc>
+                <a:extLst>
+                  <a:ext uri="{0D108BD9-81ED-4DB2-BD59-A6C34878D82A}">
+                    <a16:rowId xmlns:a16="http://schemas.microsoft.com/office/drawing/2014/main" val="10002"/>
+                  </a:ext>
+                </a:extLst>
               </a:tr>
               <a:tr h="536040">
                 <a:tc>
                   <a:txBody>
-                    <a:bodyPr lIns="36000" tIns="36000" rIns="36000" bIns="36000" anchor="t">
-                      <a:noAutofit/>
-                    </a:bodyPr>
+                    <a:bodyPr/>
+                    <a:lstStyle/>
                     <a:p>
                       <a:pPr defTabSz="914400">
                         <a:lnSpc>
@@ -5758,7 +6178,7 @@
                       </a:endParaRPr>
                     </a:p>
                   </a:txBody>
-                  <a:tcPr anchor="t" marL="36000" marR="36000" marT="36000" marB="36000">
+                  <a:tcPr marL="36000" marR="36000" marT="36000" marB="36000">
                     <a:lnL w="7200">
                       <a:solidFill>
                         <a:srgbClr val="000000"/>
@@ -5788,9 +6208,8 @@
                 </a:tc>
                 <a:tc>
                   <a:txBody>
-                    <a:bodyPr lIns="36000" tIns="36000" rIns="36000" bIns="36000" anchor="t">
-                      <a:noAutofit/>
-                    </a:bodyPr>
+                    <a:bodyPr/>
+                    <a:lstStyle/>
                     <a:p>
                       <a:pPr defTabSz="914400">
                         <a:lnSpc>
@@ -5819,7 +6238,7 @@
                       </a:endParaRPr>
                     </a:p>
                   </a:txBody>
-                  <a:tcPr anchor="t" marL="36000" marR="36000" marT="36000" marB="36000">
+                  <a:tcPr marL="36000" marR="36000" marT="36000" marB="36000">
                     <a:lnL w="7200">
                       <a:solidFill>
                         <a:srgbClr val="000000"/>
@@ -5849,9 +6268,8 @@
                 </a:tc>
                 <a:tc>
                   <a:txBody>
-                    <a:bodyPr lIns="36000" tIns="36000" rIns="36000" bIns="36000" anchor="t">
-                      <a:noAutofit/>
-                    </a:bodyPr>
+                    <a:bodyPr/>
+                    <a:lstStyle/>
                     <a:p>
                       <a:pPr defTabSz="914400">
                         <a:lnSpc>
@@ -5880,7 +6298,7 @@
                       </a:endParaRPr>
                     </a:p>
                   </a:txBody>
-                  <a:tcPr anchor="t" marL="36000" marR="36000" marT="36000" marB="36000">
+                  <a:tcPr marL="36000" marR="36000" marT="36000" marB="36000">
                     <a:lnL w="7200">
                       <a:solidFill>
                         <a:srgbClr val="000000"/>
@@ -5910,9 +6328,8 @@
                 </a:tc>
                 <a:tc>
                   <a:txBody>
-                    <a:bodyPr lIns="36000" tIns="36000" rIns="36000" bIns="36000" anchor="t">
-                      <a:noAutofit/>
-                    </a:bodyPr>
+                    <a:bodyPr/>
+                    <a:lstStyle/>
                     <a:p>
                       <a:pPr defTabSz="914400">
                         <a:lnSpc>
@@ -5941,7 +6358,7 @@
                       </a:endParaRPr>
                     </a:p>
                   </a:txBody>
-                  <a:tcPr anchor="t" marL="36000" marR="36000" marT="36000" marB="36000">
+                  <a:tcPr marL="36000" marR="36000" marT="36000" marB="36000">
                     <a:lnL w="7200">
                       <a:solidFill>
                         <a:srgbClr val="000000"/>
@@ -5969,6 +6386,11 @@
                     <a:noFill/>
                   </a:tcPr>
                 </a:tc>
+                <a:extLst>
+                  <a:ext uri="{0D108BD9-81ED-4DB2-BD59-A6C34878D82A}">
+                    <a16:rowId xmlns:a16="http://schemas.microsoft.com/office/drawing/2014/main" val="10003"/>
+                  </a:ext>
+                </a:extLst>
               </a:tr>
             </a:tbl>
           </a:graphicData>
@@ -5994,15 +6416,22 @@
           </a:ln>
         </p:spPr>
         <p:style>
-          <a:lnRef idx="0"/>
-          <a:fillRef idx="0"/>
-          <a:effectRef idx="0"/>
+          <a:lnRef idx="0">
+            <a:scrgbClr r="0" g="0" b="0"/>
+          </a:lnRef>
+          <a:fillRef idx="0">
+            <a:scrgbClr r="0" g="0" b="0"/>
+          </a:fillRef>
+          <a:effectRef idx="0">
+            <a:scrgbClr r="0" g="0" b="0"/>
+          </a:effectRef>
           <a:fontRef idx="minor"/>
         </p:style>
         <p:txBody>
           <a:bodyPr lIns="90000" tIns="45000" rIns="90000" bIns="45000" anchor="t">
             <a:spAutoFit/>
           </a:bodyPr>
+          <a:lstStyle/>
           <a:p>
             <a:pPr algn="ctr" defTabSz="914400">
               <a:lnSpc>
@@ -6047,6 +6476,7 @@
         <p:spPr/>
         <p:txBody>
           <a:bodyPr/>
+          <a:lstStyle/>
           <a:p>
             <a:r>
               <a:t>Causal Effect Estimation</a:t>
@@ -6056,19 +6486,14 @@
       </p:sp>
     </p:spTree>
   </p:cSld>
-  <mc:AlternateContent>
-    <mc:Choice Requires="p14">
-      <p:transition spd="slow" p14:dur="2000"/>
-    </mc:Choice>
-    <mc:Fallback>
-      <p:transition spd="slow"/>
-    </mc:Fallback>
-  </mc:AlternateContent>
+  <p:clrMapOvr>
+    <a:masterClrMapping/>
+  </p:clrMapOvr>
 </p:sld>
 </file>
 
 <file path=ppt/slides/slide4.xml><?xml version="1.0" encoding="utf-8"?>
-<p:sld xmlns:a="http://schemas.openxmlformats.org/drawingml/2006/main" xmlns:p="http://schemas.openxmlformats.org/presentationml/2006/main" xmlns:r="http://schemas.openxmlformats.org/officeDocument/2006/relationships" xmlns:p14="http://schemas.microsoft.com/office/powerpoint/2010/main" xmlns:p15="http://schemas.microsoft.com/office/powerpoint/2012/main" xmlns:mc="http://schemas.openxmlformats.org/markup-compatibility/2006">
+<p:sld xmlns:a="http://schemas.openxmlformats.org/drawingml/2006/main" xmlns:r="http://schemas.openxmlformats.org/officeDocument/2006/relationships" xmlns:p="http://schemas.openxmlformats.org/presentationml/2006/main">
   <p:cSld>
     <p:spTree>
       <p:nvGrpSpPr>
@@ -6111,6 +6536,7 @@
           <a:bodyPr lIns="91440" tIns="45720" rIns="91440" bIns="45720" anchor="ctr">
             <a:noAutofit/>
           </a:bodyPr>
+          <a:lstStyle/>
           <a:p>
             <a:pPr indent="0" algn="l" defTabSz="914400">
               <a:lnSpc>
@@ -6168,6 +6594,7 @@
           <a:bodyPr lIns="91440" tIns="45720" rIns="91440" bIns="45720" anchor="t">
             <a:noAutofit/>
           </a:bodyPr>
+          <a:lstStyle/>
           <a:p>
             <a:pPr marL="228600" indent="-228600" algn="l" defTabSz="914400">
               <a:lnSpc>
@@ -6183,7 +6610,7 @@
               <a:buChar char="•"/>
             </a:pPr>
             <a:r>
-              <a:rPr lang="en-GB" sz="2000" b="0" u="none" strike="noStrike">
+              <a:rPr lang="en-GB" sz="2000" b="0" u="none" strike="noStrike" dirty="0">
                 <a:solidFill>
                   <a:schemeClr val="dk1"/>
                 </a:solidFill>
@@ -6194,7 +6621,7 @@
               </a:rPr>
               <a:t>Before choosing a method, practical questions must be answered</a:t>
             </a:r>
-            <a:endParaRPr lang="en-GB" sz="2000" b="0" u="none" strike="noStrike">
+            <a:endParaRPr lang="en-GB" sz="2000" b="0" u="none" strike="noStrike" dirty="0">
               <a:solidFill>
                 <a:schemeClr val="dk1"/>
               </a:solidFill>
@@ -6204,7 +6631,7 @@
             </a:endParaRPr>
           </a:p>
           <a:p>
-            <a:pPr marL="457200" indent="-457200" algn="l" defTabSz="914400">
+            <a:pPr algn="l" defTabSz="914400">
               <a:lnSpc>
                 <a:spcPct val="90000"/>
               </a:lnSpc>
@@ -6214,22 +6641,20 @@
               <a:buClr>
                 <a:srgbClr val="000000"/>
               </a:buClr>
-              <a:buFont typeface="Aptos Display"/>
-              <a:buAutoNum type="arabicPeriod"/>
-            </a:pPr>
-            <a:r>
-              <a:rPr lang="en-GB" sz="2000" b="0" u="none" strike="noStrike">
-                <a:solidFill>
-                  <a:schemeClr val="dk1"/>
-                </a:solidFill>
-                <a:effectLst/>
-                <a:uFillTx/>
-                <a:latin typeface="Calibri"/>
-                <a:ea typeface="Calibri"/>
-              </a:rPr>
-              <a:t>What is the form of the effect?</a:t>
-            </a:r>
-            <a:endParaRPr lang="en-GB" sz="2000" b="0" u="none" strike="noStrike">
+            </a:pPr>
+            <a:r>
+              <a:rPr lang="en-GB" sz="2000" b="0" u="none" strike="noStrike" dirty="0">
+                <a:solidFill>
+                  <a:schemeClr val="dk1"/>
+                </a:solidFill>
+                <a:effectLst/>
+                <a:uFillTx/>
+                <a:latin typeface="Calibri"/>
+                <a:ea typeface="Calibri"/>
+              </a:rPr>
+              <a:t>1. What is the form of the effect?</a:t>
+            </a:r>
+            <a:endParaRPr lang="en-GB" sz="2000" b="0" u="none" strike="noStrike" dirty="0">
               <a:solidFill>
                 <a:schemeClr val="dk1"/>
               </a:solidFill>
@@ -6253,7 +6678,7 @@
               <a:buChar char="•"/>
             </a:pPr>
             <a:r>
-              <a:rPr lang="en-GB" sz="1800" b="0" u="none" strike="noStrike">
+              <a:rPr lang="en-GB" sz="1800" b="0" u="none" strike="noStrike" dirty="0">
                 <a:solidFill>
                   <a:schemeClr val="dk1"/>
                 </a:solidFill>
@@ -6264,7 +6689,7 @@
               </a:rPr>
               <a:t>Is the relationship between treatment and outcome linear or non-linear? Assuming a linear model when reality is not, will lead to poor estimation quality.</a:t>
             </a:r>
-            <a:endParaRPr lang="en-GB" sz="1800" b="0" u="none" strike="noStrike">
+            <a:endParaRPr lang="en-GB" sz="1800" b="0" u="none" strike="noStrike" dirty="0">
               <a:solidFill>
                 <a:schemeClr val="dk1"/>
               </a:solidFill>
@@ -6274,7 +6699,7 @@
             </a:endParaRPr>
           </a:p>
           <a:p>
-            <a:pPr marL="457200" indent="-457200" algn="l" defTabSz="914400">
+            <a:pPr algn="l" defTabSz="914400">
               <a:lnSpc>
                 <a:spcPct val="90000"/>
               </a:lnSpc>
@@ -6284,22 +6709,31 @@
               <a:buClr>
                 <a:srgbClr val="000000"/>
               </a:buClr>
-              <a:buFont typeface="Aptos Display"/>
-              <a:buAutoNum type="arabicPeriod"/>
-            </a:pPr>
-            <a:r>
-              <a:rPr lang="en-GB" sz="2000" b="0" u="none" strike="noStrike">
-                <a:solidFill>
-                  <a:schemeClr val="dk1"/>
-                </a:solidFill>
-                <a:effectLst/>
-                <a:uFillTx/>
-                <a:latin typeface="Calibri"/>
-                <a:ea typeface="Calibri"/>
-              </a:rPr>
-              <a:t>What type of data do you have? </a:t>
-            </a:r>
-            <a:endParaRPr lang="en-GB" sz="2000" b="0" u="none" strike="noStrike">
+            </a:pPr>
+            <a:br>
+              <a:rPr lang="en-GB" sz="2000" b="0" u="none" strike="noStrike" dirty="0">
+                <a:solidFill>
+                  <a:schemeClr val="dk1"/>
+                </a:solidFill>
+                <a:effectLst/>
+                <a:uFillTx/>
+                <a:latin typeface="Calibri"/>
+                <a:ea typeface="Calibri"/>
+              </a:rPr>
+            </a:br>
+            <a:r>
+              <a:rPr lang="en-GB" sz="2000" b="0" u="none" strike="noStrike" dirty="0">
+                <a:solidFill>
+                  <a:schemeClr val="dk1"/>
+                </a:solidFill>
+                <a:effectLst/>
+                <a:uFillTx/>
+                <a:latin typeface="Calibri"/>
+                <a:ea typeface="Calibri"/>
+              </a:rPr>
+              <a:t>2. What type of data do you have? </a:t>
+            </a:r>
+            <a:endParaRPr lang="en-GB" sz="2000" b="0" u="none" strike="noStrike" dirty="0">
               <a:solidFill>
                 <a:schemeClr val="dk1"/>
               </a:solidFill>
@@ -6323,7 +6757,7 @@
               <a:buChar char="•"/>
             </a:pPr>
             <a:r>
-              <a:rPr lang="en-GB" sz="1800" b="0" u="none" strike="noStrike">
+              <a:rPr lang="en-GB" sz="1800" b="0" u="none" strike="noStrike" dirty="0">
                 <a:solidFill>
                   <a:schemeClr val="dk1"/>
                 </a:solidFill>
@@ -6334,7 +6768,7 @@
               </a:rPr>
               <a:t>Treatment, Outcome, Covariates (continuous, binary, ordinal…). Some estimation methods work only for specific types of data.</a:t>
             </a:r>
-            <a:endParaRPr lang="en-GB" sz="1800" b="0" u="none" strike="noStrike">
+            <a:endParaRPr lang="en-GB" sz="1800" b="0" u="none" strike="noStrike" dirty="0">
               <a:solidFill>
                 <a:schemeClr val="dk1"/>
               </a:solidFill>
@@ -6406,7 +6840,7 @@
                 <a:latin typeface="Calibri"/>
                 <a:ea typeface="Calibri"/>
               </a:rPr>
-              <a:t>&lt;number&gt;</a:t>
+              <a:t>4</a:t>
             </a:fld>
             <a:endParaRPr lang="en-GB" sz="900" b="0" u="none" strike="noStrike">
               <a:solidFill>
@@ -6432,6 +6866,7 @@
         <p:spPr/>
         <p:txBody>
           <a:bodyPr/>
+          <a:lstStyle/>
           <a:p>
             <a:r>
               <a:t>Causal Effect Estimation</a:t>
@@ -6441,19 +6876,14 @@
       </p:sp>
     </p:spTree>
   </p:cSld>
-  <mc:AlternateContent>
-    <mc:Choice Requires="p14">
-      <p:transition spd="slow" p14:dur="2000"/>
-    </mc:Choice>
-    <mc:Fallback>
-      <p:transition spd="slow"/>
-    </mc:Fallback>
-  </mc:AlternateContent>
+  <p:clrMapOvr>
+    <a:masterClrMapping/>
+  </p:clrMapOvr>
 </p:sld>
 </file>
 
 <file path=ppt/slides/slide5.xml><?xml version="1.0" encoding="utf-8"?>
-<p:sld xmlns:a="http://schemas.openxmlformats.org/drawingml/2006/main" xmlns:p="http://schemas.openxmlformats.org/presentationml/2006/main" xmlns:r="http://schemas.openxmlformats.org/officeDocument/2006/relationships" xmlns:p14="http://schemas.microsoft.com/office/powerpoint/2010/main" xmlns:p15="http://schemas.microsoft.com/office/powerpoint/2012/main" xmlns:mc="http://schemas.openxmlformats.org/markup-compatibility/2006">
+<p:sld xmlns:a="http://schemas.openxmlformats.org/drawingml/2006/main" xmlns:r="http://schemas.openxmlformats.org/officeDocument/2006/relationships" xmlns:p="http://schemas.openxmlformats.org/presentationml/2006/main">
   <p:cSld>
     <p:spTree>
       <p:nvGrpSpPr>
@@ -6496,6 +6926,7 @@
           <a:bodyPr lIns="91440" tIns="45720" rIns="91440" bIns="45720" anchor="ctr">
             <a:noAutofit/>
           </a:bodyPr>
+          <a:lstStyle/>
           <a:p>
             <a:pPr indent="0" algn="l" defTabSz="914400">
               <a:lnSpc>
@@ -6553,6 +6984,7 @@
           <a:bodyPr lIns="91440" tIns="45720" rIns="91440" bIns="45720" anchor="t">
             <a:noAutofit/>
           </a:bodyPr>
+          <a:lstStyle/>
           <a:p>
             <a:pPr marL="228600" indent="-228600" algn="l" defTabSz="914400">
               <a:lnSpc>
@@ -6568,7 +7000,7 @@
               <a:buChar char="•"/>
             </a:pPr>
             <a:r>
-              <a:rPr lang="en-GB" sz="2000" b="0" u="none" strike="noStrike">
+              <a:rPr lang="en-GB" sz="2000" b="0" u="none" strike="noStrike" dirty="0">
                 <a:solidFill>
                   <a:schemeClr val="dk1"/>
                 </a:solidFill>
@@ -6579,7 +7011,38 @@
               </a:rPr>
               <a:t>Before choosing a method, practical questions must be answered</a:t>
             </a:r>
-            <a:endParaRPr lang="en-GB" sz="2000" b="0" u="none" strike="noStrike">
+            <a:endParaRPr lang="en-GB" sz="2000" b="0" dirty="0">
+              <a:solidFill>
+                <a:schemeClr val="dk1"/>
+              </a:solidFill>
+              <a:latin typeface="Calibri"/>
+            </a:endParaRPr>
+          </a:p>
+          <a:p>
+            <a:pPr algn="l" defTabSz="914400">
+              <a:lnSpc>
+                <a:spcPct val="90000"/>
+              </a:lnSpc>
+              <a:spcBef>
+                <a:spcPts val="1001"/>
+              </a:spcBef>
+              <a:buClr>
+                <a:srgbClr val="000000"/>
+              </a:buClr>
+            </a:pPr>
+            <a:r>
+              <a:rPr lang="en-GB" sz="2000" b="0" u="none" strike="noStrike" dirty="0">
+                <a:solidFill>
+                  <a:schemeClr val="dk1"/>
+                </a:solidFill>
+                <a:effectLst/>
+                <a:uFillTx/>
+                <a:latin typeface="Calibri"/>
+                <a:ea typeface="Calibri"/>
+              </a:rPr>
+              <a:t>3. Do you need to transform the data?</a:t>
+            </a:r>
+            <a:endParaRPr lang="en-GB" sz="2000" b="0" u="none" strike="noStrike" dirty="0">
               <a:solidFill>
                 <a:schemeClr val="dk1"/>
               </a:solidFill>
@@ -6589,28 +7052,75 @@
             </a:endParaRPr>
           </a:p>
           <a:p>
-            <a:pPr marL="457200" indent="0" algn="l" defTabSz="914400">
+            <a:pPr marL="685800" lvl="1" indent="-228600" algn="l" defTabSz="914400">
               <a:lnSpc>
                 <a:spcPct val="90000"/>
               </a:lnSpc>
               <a:spcBef>
-                <a:spcPts val="1001"/>
+                <a:spcPts val="499"/>
               </a:spcBef>
-              <a:buNone/>
-            </a:pPr>
-            <a:r>
-              <a:rPr lang="en-GB" sz="2000" b="0" u="none" strike="noStrike">
-                <a:solidFill>
-                  <a:schemeClr val="dk1"/>
-                </a:solidFill>
-                <a:effectLst/>
-                <a:uFillTx/>
-                <a:latin typeface="Calibri"/>
-                <a:ea typeface="Calibri"/>
-              </a:rPr>
-              <a:t>3. Do you need to transform the data?</a:t>
-            </a:r>
-            <a:endParaRPr lang="en-GB" sz="2000" b="0" u="none" strike="noStrike">
+              <a:buClr>
+                <a:srgbClr val="000000"/>
+              </a:buClr>
+              <a:buFont typeface="Arial"/>
+              <a:buChar char="•"/>
+            </a:pPr>
+            <a:r>
+              <a:rPr lang="en-GB" sz="1800" b="0" u="none" strike="noStrike" dirty="0">
+                <a:solidFill>
+                  <a:schemeClr val="dk1"/>
+                </a:solidFill>
+                <a:effectLst/>
+                <a:uFillTx/>
+                <a:latin typeface="Calibri"/>
+                <a:ea typeface="Calibri"/>
+              </a:rPr>
+              <a:t>No single answer here. Avoid transformations that change the identification results (e.g., feature engineering and dimensionality reduction). Can you interpret the results after transformation (e.g., what is the effect of a log(T) on Y)?</a:t>
+            </a:r>
+            <a:endParaRPr lang="en-GB" dirty="0">
+              <a:solidFill>
+                <a:schemeClr val="dk1"/>
+              </a:solidFill>
+              <a:latin typeface="Calibri"/>
+              <a:ea typeface="Cambria"/>
+            </a:endParaRPr>
+          </a:p>
+          <a:p>
+            <a:pPr lvl="1" algn="l" defTabSz="914400">
+              <a:lnSpc>
+                <a:spcPct val="90000"/>
+              </a:lnSpc>
+              <a:spcBef>
+                <a:spcPts val="499"/>
+              </a:spcBef>
+              <a:buClr>
+                <a:srgbClr val="000000"/>
+              </a:buClr>
+            </a:pPr>
+            <a:br>
+              <a:rPr lang="en-GB" sz="2000" b="0" u="none" strike="noStrike" dirty="0">
+                <a:solidFill>
+                  <a:schemeClr val="dk1"/>
+                </a:solidFill>
+                <a:effectLst/>
+                <a:uFillTx/>
+                <a:latin typeface="Calibri"/>
+                <a:ea typeface="Calibri"/>
+              </a:rPr>
+            </a:br>
+            <a:r>
+              <a:rPr lang="en-GB" sz="2000" b="0" u="none" strike="noStrike" dirty="0">
+                <a:solidFill>
+                  <a:schemeClr val="dk1"/>
+                </a:solidFill>
+                <a:effectLst/>
+                <a:uFillTx/>
+                <a:latin typeface="Calibri"/>
+                <a:ea typeface="Calibri"/>
+              </a:rPr>
+              <a:t>4. How large is the adjustment set?</a:t>
+            </a:r>
+            <a:endParaRPr lang="en-GB" sz="2000" b="0" u="none" strike="noStrike" dirty="0">
               <a:solidFill>
                 <a:schemeClr val="dk1"/>
               </a:solidFill>
@@ -6634,42 +7144,18 @@
               <a:buChar char="•"/>
             </a:pPr>
             <a:r>
-              <a:rPr lang="en-GB" sz="1800" b="0" u="none" strike="noStrike">
-                <a:solidFill>
-                  <a:schemeClr val="dk1"/>
-                </a:solidFill>
-                <a:effectLst/>
-                <a:uFillTx/>
-                <a:latin typeface="Calibri"/>
-                <a:ea typeface="Calibri"/>
-              </a:rPr>
-              <a:t>No single answer here. Avoid transformations that change the identification results </a:t>
-            </a:r>
-            <a:r>
-              <a:rPr lang="en-GB" sz="1800" b="0" u="none" strike="noStrike">
-                <a:solidFill>
-                  <a:schemeClr val="dk1"/>
-                </a:solidFill>
-                <a:effectLst/>
-                <a:uFillTx/>
-                <a:latin typeface="Calibri"/>
-                <a:ea typeface="Calibri"/>
-              </a:rPr>
-              <a:t>(e.g., feature engineering and dimensionality reduction). Can you interpret the </a:t>
-            </a:r>
-            <a:r>
-              <a:rPr lang="en-GB" sz="1800" b="0" u="none" strike="noStrike">
-                <a:solidFill>
-                  <a:schemeClr val="dk1"/>
-                </a:solidFill>
-                <a:effectLst/>
-                <a:uFillTx/>
-                <a:latin typeface="Calibri"/>
-                <a:ea typeface="Calibri"/>
-              </a:rPr>
-              <a:t>results after transformation (e.g., what is the effect of a log(T) on Y)?</a:t>
-            </a:r>
-            <a:endParaRPr lang="en-GB" sz="1800" b="0" u="none" strike="noStrike">
+              <a:rPr lang="en-GB" sz="1800" b="0" u="none" strike="noStrike" dirty="0">
+                <a:solidFill>
+                  <a:schemeClr val="dk1"/>
+                </a:solidFill>
+                <a:effectLst/>
+                <a:uFillTx/>
+                <a:latin typeface="Calibri"/>
+                <a:ea typeface="Calibri"/>
+              </a:rPr>
+              <a:t>Few confounders: classical regression works well.</a:t>
+            </a:r>
+            <a:endParaRPr lang="en-GB" sz="1800" b="0" u="none" strike="noStrike" dirty="0">
               <a:solidFill>
                 <a:schemeClr val="dk1"/>
               </a:solidFill>
@@ -6679,28 +7165,56 @@
             </a:endParaRPr>
           </a:p>
           <a:p>
-            <a:pPr marL="457200" indent="0" algn="l" defTabSz="914400">
+            <a:pPr marL="685800" lvl="1" indent="-228600" algn="l" defTabSz="914400">
               <a:lnSpc>
                 <a:spcPct val="90000"/>
               </a:lnSpc>
               <a:spcBef>
-                <a:spcPts val="1001"/>
+                <a:spcPts val="499"/>
               </a:spcBef>
-              <a:buNone/>
-            </a:pPr>
-            <a:r>
-              <a:rPr lang="en-GB" sz="2000" b="0" u="none" strike="noStrike">
-                <a:solidFill>
-                  <a:schemeClr val="dk1"/>
-                </a:solidFill>
-                <a:effectLst/>
-                <a:uFillTx/>
-                <a:latin typeface="Calibri"/>
-                <a:ea typeface="Calibri"/>
-              </a:rPr>
-              <a:t>4.  How large is the adjustment set?</a:t>
-            </a:r>
-            <a:endParaRPr lang="en-GB" sz="2000" b="0" u="none" strike="noStrike">
+              <a:buClr>
+                <a:srgbClr val="000000"/>
+              </a:buClr>
+              <a:buFont typeface="Arial"/>
+              <a:buChar char="•"/>
+            </a:pPr>
+            <a:r>
+              <a:rPr lang="en-GB" sz="1800" b="0" u="none" strike="noStrike" dirty="0">
+                <a:solidFill>
+                  <a:schemeClr val="dk1"/>
+                </a:solidFill>
+                <a:effectLst/>
+                <a:uFillTx/>
+                <a:latin typeface="Calibri"/>
+                <a:ea typeface="Calibri"/>
+              </a:rPr>
+              <a:t>Many covariates (high-dimensional setting): use methods that separate the estimation of confounding from the estimation of the treatment effect (e.g., </a:t>
+            </a:r>
+            <a:r>
+              <a:rPr lang="en-GB" sz="1800" b="0" u="none" strike="noStrike" dirty="0" err="1">
+                <a:solidFill>
+                  <a:schemeClr val="dk1"/>
+                </a:solidFill>
+                <a:effectLst/>
+                <a:uFillTx/>
+                <a:latin typeface="Calibri"/>
+                <a:ea typeface="Calibri"/>
+              </a:rPr>
+              <a:t>DoubleML</a:t>
+            </a:r>
+            <a:r>
+              <a:rPr lang="en-GB" sz="1800" b="0" u="none" strike="noStrike" dirty="0">
+                <a:solidFill>
+                  <a:schemeClr val="dk1"/>
+                </a:solidFill>
+                <a:effectLst/>
+                <a:uFillTx/>
+                <a:latin typeface="Calibri"/>
+                <a:ea typeface="Calibri"/>
+              </a:rPr>
+              <a:t>).</a:t>
+            </a:r>
+            <a:endParaRPr lang="en-GB" sz="1800" b="0" u="none" strike="noStrike" dirty="0">
               <a:solidFill>
                 <a:schemeClr val="dk1"/>
               </a:solidFill>
@@ -6710,100 +7224,6 @@
             </a:endParaRPr>
           </a:p>
           <a:p>
-            <a:pPr marL="685800" lvl="1" indent="-228600" algn="l" defTabSz="914400">
-              <a:lnSpc>
-                <a:spcPct val="90000"/>
-              </a:lnSpc>
-              <a:spcBef>
-                <a:spcPts val="499"/>
-              </a:spcBef>
-              <a:buClr>
-                <a:srgbClr val="000000"/>
-              </a:buClr>
-              <a:buFont typeface="Arial"/>
-              <a:buChar char="•"/>
-            </a:pPr>
-            <a:r>
-              <a:rPr lang="en-GB" sz="1800" b="0" u="none" strike="noStrike">
-                <a:solidFill>
-                  <a:schemeClr val="dk1"/>
-                </a:solidFill>
-                <a:effectLst/>
-                <a:uFillTx/>
-                <a:latin typeface="Calibri"/>
-                <a:ea typeface="Calibri"/>
-              </a:rPr>
-              <a:t>Few confounders: classical regression works well.</a:t>
-            </a:r>
-            <a:endParaRPr lang="en-GB" sz="1800" b="0" u="none" strike="noStrike">
-              <a:solidFill>
-                <a:schemeClr val="dk1"/>
-              </a:solidFill>
-              <a:effectLst/>
-              <a:uFillTx/>
-              <a:latin typeface="Calibri"/>
-            </a:endParaRPr>
-          </a:p>
-          <a:p>
-            <a:pPr marL="685800" lvl="1" indent="-228600" algn="l" defTabSz="914400">
-              <a:lnSpc>
-                <a:spcPct val="90000"/>
-              </a:lnSpc>
-              <a:spcBef>
-                <a:spcPts val="499"/>
-              </a:spcBef>
-              <a:buClr>
-                <a:srgbClr val="000000"/>
-              </a:buClr>
-              <a:buFont typeface="Arial"/>
-              <a:buChar char="•"/>
-            </a:pPr>
-            <a:r>
-              <a:rPr lang="en-GB" sz="1800" b="0" u="none" strike="noStrike">
-                <a:solidFill>
-                  <a:schemeClr val="dk1"/>
-                </a:solidFill>
-                <a:effectLst/>
-                <a:uFillTx/>
-                <a:latin typeface="Calibri"/>
-                <a:ea typeface="Calibri"/>
-              </a:rPr>
-              <a:t>Many covariates (high-dimensional setting): use methods that separate the </a:t>
-            </a:r>
-            <a:r>
-              <a:rPr lang="en-GB" sz="1800" b="0" u="none" strike="noStrike">
-                <a:solidFill>
-                  <a:schemeClr val="dk1"/>
-                </a:solidFill>
-                <a:effectLst/>
-                <a:uFillTx/>
-                <a:latin typeface="Calibri"/>
-                <a:ea typeface="Calibri"/>
-              </a:rPr>
-              <a:t>estimation of confounding from the estimation of the treatment effect (e.g., </a:t>
-            </a:r>
-            <a:r>
-              <a:rPr lang="en-GB" sz="1800" b="0" u="none" strike="noStrike">
-                <a:solidFill>
-                  <a:schemeClr val="dk1"/>
-                </a:solidFill>
-                <a:effectLst/>
-                <a:uFillTx/>
-                <a:latin typeface="Calibri"/>
-                <a:ea typeface="Calibri"/>
-              </a:rPr>
-              <a:t>DoubleML).</a:t>
-            </a:r>
-            <a:endParaRPr lang="en-GB" sz="1800" b="0" u="none" strike="noStrike">
-              <a:solidFill>
-                <a:schemeClr val="dk1"/>
-              </a:solidFill>
-              <a:effectLst/>
-              <a:uFillTx/>
-              <a:latin typeface="Calibri"/>
-            </a:endParaRPr>
-          </a:p>
-          <a:p>
             <a:pPr indent="0" algn="l" defTabSz="914400">
               <a:lnSpc>
                 <a:spcPct val="90000"/>
@@ -6813,7 +7233,7 @@
               </a:spcBef>
               <a:buNone/>
             </a:pPr>
-            <a:endParaRPr lang="en-GB" sz="2000" b="0" u="none" strike="noStrike">
+            <a:endParaRPr lang="en-GB" sz="2000" b="0" u="none" strike="noStrike" dirty="0">
               <a:solidFill>
                 <a:schemeClr val="dk1"/>
               </a:solidFill>
@@ -6885,7 +7305,7 @@
                 <a:latin typeface="Calibri"/>
                 <a:ea typeface="Calibri"/>
               </a:rPr>
-              <a:t>&lt;number&gt;</a:t>
+              <a:t>5</a:t>
             </a:fld>
             <a:endParaRPr lang="en-GB" sz="900" b="0" u="none" strike="noStrike">
               <a:solidFill>
@@ -6911,6 +7331,7 @@
         <p:spPr/>
         <p:txBody>
           <a:bodyPr/>
+          <a:lstStyle/>
           <a:p>
             <a:r>
               <a:t>Causal Effect Estimation</a:t>
@@ -6920,19 +7341,14 @@
       </p:sp>
     </p:spTree>
   </p:cSld>
-  <mc:AlternateContent>
-    <mc:Choice Requires="p14">
-      <p:transition spd="slow" p14:dur="2000"/>
-    </mc:Choice>
-    <mc:Fallback>
-      <p:transition spd="slow"/>
-    </mc:Fallback>
-  </mc:AlternateContent>
+  <p:clrMapOvr>
+    <a:masterClrMapping/>
+  </p:clrMapOvr>
 </p:sld>
 </file>
 
 <file path=ppt/slides/slide6.xml><?xml version="1.0" encoding="utf-8"?>
-<p:sld xmlns:a="http://schemas.openxmlformats.org/drawingml/2006/main" xmlns:p="http://schemas.openxmlformats.org/presentationml/2006/main" xmlns:r="http://schemas.openxmlformats.org/officeDocument/2006/relationships" xmlns:p14="http://schemas.microsoft.com/office/powerpoint/2010/main" xmlns:p15="http://schemas.microsoft.com/office/powerpoint/2012/main" xmlns:mc="http://schemas.openxmlformats.org/markup-compatibility/2006">
+<p:sld xmlns:a="http://schemas.openxmlformats.org/drawingml/2006/main" xmlns:r="http://schemas.openxmlformats.org/officeDocument/2006/relationships" xmlns:p="http://schemas.openxmlformats.org/presentationml/2006/main">
   <p:cSld>
     <p:spTree>
       <p:nvGrpSpPr>
@@ -6975,6 +7391,7 @@
           <a:bodyPr lIns="91440" tIns="45720" rIns="91440" bIns="45720" anchor="ctr">
             <a:noAutofit/>
           </a:bodyPr>
+          <a:lstStyle/>
           <a:p>
             <a:pPr indent="0" algn="l" defTabSz="914400">
               <a:lnSpc>
@@ -7032,6 +7449,7 @@
           <a:bodyPr lIns="91440" tIns="45720" rIns="91440" bIns="45720" anchor="t">
             <a:noAutofit/>
           </a:bodyPr>
+          <a:lstStyle/>
           <a:p>
             <a:pPr marL="228600" indent="-228600" algn="l" defTabSz="914400">
               <a:lnSpc>
@@ -7047,7 +7465,7 @@
               <a:buChar char="•"/>
             </a:pPr>
             <a:r>
-              <a:rPr lang="en-GB" sz="2000" b="1" u="none" strike="noStrike">
+              <a:rPr lang="en-GB" sz="1800" b="1" u="none" strike="noStrike" dirty="0">
                 <a:solidFill>
                   <a:schemeClr val="dk1"/>
                 </a:solidFill>
@@ -7059,7 +7477,7 @@
               <a:t>Problem it solves: </a:t>
             </a:r>
             <a:r>
-              <a:rPr lang="en-GB" sz="2000" b="0" u="none" strike="noStrike">
+              <a:rPr lang="en-GB" sz="1800" b="0" u="none" strike="noStrike" dirty="0">
                 <a:solidFill>
                   <a:schemeClr val="dk1"/>
                 </a:solidFill>
@@ -7070,7 +7488,7 @@
               </a:rPr>
               <a:t>How do I estimate the effect of the treatment on the outcome while controlling for confounders?</a:t>
             </a:r>
-            <a:endParaRPr lang="en-GB" sz="2000" b="0" u="none" strike="noStrike">
+            <a:endParaRPr lang="en-GB" sz="1800" b="0" u="none" strike="noStrike" dirty="0">
               <a:solidFill>
                 <a:schemeClr val="dk1"/>
               </a:solidFill>
@@ -7094,7 +7512,7 @@
               <a:buChar char="•"/>
             </a:pPr>
             <a:r>
-              <a:rPr lang="en-GB" sz="2000" b="1" u="none" strike="noStrike">
+              <a:rPr lang="en-GB" sz="1800" b="1" u="none" strike="noStrike" dirty="0">
                 <a:solidFill>
                   <a:schemeClr val="dk1"/>
                 </a:solidFill>
@@ -7106,7 +7524,7 @@
               <a:t>Key intuition: </a:t>
             </a:r>
             <a:r>
-              <a:rPr lang="en-GB" sz="2000" b="0" u="none" strike="noStrike">
+              <a:rPr lang="en-GB" sz="1800" b="0" u="none" strike="noStrike" dirty="0">
                 <a:solidFill>
                   <a:schemeClr val="dk1"/>
                 </a:solidFill>
@@ -7117,7 +7535,7 @@
               </a:rPr>
               <a:t>Model the outcome as a function of both the treatment and the covariates. The treatment coefficient (or marginal effect) is your Average Treatment Effect (ATE).</a:t>
             </a:r>
-            <a:endParaRPr lang="en-GB" sz="2000" b="0" u="none" strike="noStrike">
+            <a:endParaRPr lang="en-GB" sz="1800" b="0" u="none" strike="noStrike" dirty="0">
               <a:solidFill>
                 <a:schemeClr val="dk1"/>
               </a:solidFill>
@@ -7141,7 +7559,7 @@
               <a:buChar char="•"/>
             </a:pPr>
             <a:r>
-              <a:rPr lang="en-GB" sz="1800" b="0" u="none" strike="noStrike">
+              <a:rPr lang="en-GB" sz="1600" b="0" u="none" strike="noStrike" dirty="0">
                 <a:solidFill>
                   <a:schemeClr val="dk1"/>
                 </a:solidFill>
@@ -7152,7 +7570,7 @@
               </a:rPr>
               <a:t>Outcome = f(Treatment, Covariates) → read off the treatment coefficient</a:t>
             </a:r>
-            <a:endParaRPr lang="en-GB" sz="1800" b="0" u="none" strike="noStrike">
+            <a:endParaRPr lang="en-GB" sz="1600" b="0" u="none" strike="noStrike" dirty="0">
               <a:solidFill>
                 <a:schemeClr val="dk1"/>
               </a:solidFill>
@@ -7176,7 +7594,7 @@
               <a:buChar char="•"/>
             </a:pPr>
             <a:r>
-              <a:rPr lang="en-GB" sz="2000" b="1" u="none" strike="noStrike">
+              <a:rPr lang="en-GB" sz="1800" b="1" u="none" strike="noStrike" dirty="0">
                 <a:solidFill>
                   <a:schemeClr val="dk1"/>
                 </a:solidFill>
@@ -7187,7 +7605,7 @@
               </a:rPr>
               <a:t>Main limitations:</a:t>
             </a:r>
-            <a:endParaRPr lang="en-GB" sz="2000" b="0" u="none" strike="noStrike">
+            <a:endParaRPr lang="en-GB" sz="1800" b="0" u="none" strike="noStrike" dirty="0">
               <a:solidFill>
                 <a:schemeClr val="dk1"/>
               </a:solidFill>
@@ -7211,7 +7629,7 @@
               <a:buChar char="•"/>
             </a:pPr>
             <a:r>
-              <a:rPr lang="en-GB" sz="1800" b="1" u="none" strike="noStrike">
+              <a:rPr lang="en-GB" sz="1600" b="1" u="none" strike="noStrike" dirty="0">
                 <a:solidFill>
                   <a:schemeClr val="dk1"/>
                 </a:solidFill>
@@ -7223,7 +7641,7 @@
               <a:t>Model misspecification: </a:t>
             </a:r>
             <a:r>
-              <a:rPr lang="en-GB" sz="1800" b="0" u="none" strike="noStrike">
+              <a:rPr lang="en-GB" sz="1600" b="0" u="none" strike="noStrike" dirty="0">
                 <a:solidFill>
                   <a:schemeClr val="dk1"/>
                 </a:solidFill>
@@ -7234,7 +7652,7 @@
               </a:rPr>
               <a:t>You must correctly specify the model form. If the true relationship is non-linear and you use a linear model, the effect estimate is biased.</a:t>
             </a:r>
-            <a:endParaRPr lang="en-GB" sz="1800" b="0" u="none" strike="noStrike">
+            <a:endParaRPr lang="en-GB" sz="1600" b="0" u="none" strike="noStrike" dirty="0">
               <a:solidFill>
                 <a:schemeClr val="dk1"/>
               </a:solidFill>
@@ -7258,7 +7676,7 @@
               <a:buChar char="•"/>
             </a:pPr>
             <a:r>
-              <a:rPr lang="en-GB" sz="1800" b="1" u="none" strike="noStrike">
+              <a:rPr lang="en-GB" sz="1600" b="1" u="none" strike="noStrike" dirty="0">
                 <a:solidFill>
                   <a:schemeClr val="dk1"/>
                 </a:solidFill>
@@ -7270,7 +7688,7 @@
               <a:t>Large adjustment sets: </a:t>
             </a:r>
             <a:r>
-              <a:rPr lang="en-GB" sz="1800" b="0" u="none" strike="noStrike">
+              <a:rPr lang="en-GB" sz="1600" b="0" u="none" strike="noStrike" dirty="0">
                 <a:solidFill>
                   <a:schemeClr val="dk1"/>
                 </a:solidFill>
@@ -7281,7 +7699,7 @@
               </a:rPr>
               <a:t>When you have many covariates, classical regression struggles</a:t>
             </a:r>
-            <a:endParaRPr lang="en-GB" sz="1800" b="0" u="none" strike="noStrike">
+            <a:endParaRPr lang="en-GB" sz="1600" b="0" u="none" strike="noStrike" dirty="0">
               <a:solidFill>
                 <a:schemeClr val="dk1"/>
               </a:solidFill>
@@ -7353,7 +7771,7 @@
                 <a:latin typeface="Calibri"/>
                 <a:ea typeface="Calibri"/>
               </a:rPr>
-              <a:t>&lt;number&gt;</a:t>
+              <a:t>6</a:t>
             </a:fld>
             <a:endParaRPr lang="en-GB" sz="900" b="0" u="none" strike="noStrike">
               <a:solidFill>
@@ -7379,28 +7797,132 @@
         <p:spPr/>
         <p:txBody>
           <a:bodyPr/>
+          <a:lstStyle/>
           <a:p>
             <a:r>
               <a:t>Causal Effect Estimation</a:t>
             </a:r>
+          </a:p>
+        </p:txBody>
+      </p:sp>
+      <p:sp>
+        <p:nvSpPr>
+          <p:cNvPr id="3" name="TextBox 23">
+            <a:extLst>
+              <a:ext uri="{FF2B5EF4-FFF2-40B4-BE49-F238E27FC236}">
+                <a16:creationId xmlns:a16="http://schemas.microsoft.com/office/drawing/2014/main" id="{3DE5C64B-AA54-BCFD-6D70-CDD2F007BAB9}"/>
+              </a:ext>
+            </a:extLst>
+          </p:cNvPr>
+          <p:cNvSpPr txBox="1"/>
+          <p:nvPr/>
+        </p:nvSpPr>
+        <p:spPr>
+          <a:xfrm>
+            <a:off x="286560" y="4214576"/>
+            <a:ext cx="5924111" cy="552544"/>
+          </a:xfrm>
+          <a:prstGeom prst="rect">
+            <a:avLst/>
+          </a:prstGeom>
+          <a:noFill/>
+          <a:ln w="0">
+            <a:noFill/>
+          </a:ln>
+        </p:spPr>
+        <p:txBody>
+          <a:bodyPr wrap="square" lIns="90000" tIns="45000" rIns="90000" bIns="45000" anchor="t">
+            <a:spAutoFit/>
+          </a:bodyPr>
+          <a:lstStyle/>
+          <a:p>
+            <a:r>
+              <a:rPr lang="en-US" sz="1000" b="0" u="none" strike="noStrike" dirty="0">
+                <a:solidFill>
+                  <a:srgbClr val="000000"/>
+                </a:solidFill>
+                <a:effectLst/>
+                <a:uFillTx/>
+                <a:latin typeface="Aptos" panose="020B0004020202020204" pitchFamily="34" charset="0"/>
+              </a:rPr>
+              <a:t> Chapter 13 - Regression. “The Effect: An Introduction to Research Design and Causality”. </a:t>
+            </a:r>
+            <a:br>
+              <a:rPr lang="en-US" sz="1000" b="0" u="none" strike="noStrike" dirty="0">
+                <a:solidFill>
+                  <a:srgbClr val="000000"/>
+                </a:solidFill>
+                <a:effectLst/>
+                <a:uFillTx/>
+                <a:latin typeface="Aptos" panose="020B0004020202020204" pitchFamily="34" charset="0"/>
+              </a:rPr>
+            </a:br>
+            <a:r>
+              <a:rPr lang="en-US" sz="1000" dirty="0">
+                <a:solidFill>
+                  <a:srgbClr val="000000"/>
+                </a:solidFill>
+                <a:latin typeface="Aptos" panose="020B0004020202020204" pitchFamily="34" charset="0"/>
+              </a:rPr>
+              <a:t>N</a:t>
+            </a:r>
+            <a:r>
+              <a:rPr lang="en-US" sz="1000" b="0" u="none" strike="noStrike" dirty="0">
+                <a:solidFill>
+                  <a:srgbClr val="000000"/>
+                </a:solidFill>
+                <a:effectLst/>
+                <a:uFillTx/>
+                <a:latin typeface="Aptos" panose="020B0004020202020204" pitchFamily="34" charset="0"/>
+              </a:rPr>
+              <a:t>ick Huntington-Klein. CRC Press </a:t>
+            </a:r>
+            <a:r>
+              <a:rPr lang="en-US" sz="1000" b="0" u="none" strike="noStrike" dirty="0">
+                <a:solidFill>
+                  <a:srgbClr val="000000"/>
+                </a:solidFill>
+                <a:effectLst/>
+                <a:uFillTx/>
+                <a:latin typeface="Aptos" panose="020B0004020202020204" pitchFamily="34" charset="0"/>
+                <a:hlinkClick r:id="rId2"/>
+              </a:rPr>
+              <a:t>https://theeffectbook.net/index.html</a:t>
+            </a:r>
+            <a:r>
+              <a:rPr lang="en-US" sz="1000" b="0" u="none" strike="noStrike" dirty="0">
+                <a:solidFill>
+                  <a:srgbClr val="000000"/>
+                </a:solidFill>
+                <a:effectLst/>
+                <a:uFillTx/>
+                <a:latin typeface="Aptos" panose="020B0004020202020204" pitchFamily="34" charset="0"/>
+              </a:rPr>
+              <a:t> </a:t>
+            </a:r>
+          </a:p>
+          <a:p>
+            <a:endParaRPr lang="en-US" sz="1000" b="0" u="none" strike="noStrike" dirty="0">
+              <a:solidFill>
+                <a:srgbClr val="000000"/>
+              </a:solidFill>
+              <a:effectLst/>
+              <a:uFillTx/>
+              <a:latin typeface="Aptos" panose="020B0004020202020204" pitchFamily="34" charset="0"/>
+            </a:endParaRPr>
           </a:p>
         </p:txBody>
       </p:sp>
     </p:spTree>
   </p:cSld>
-  <mc:AlternateContent>
-    <mc:Choice Requires="p14">
-      <p:transition spd="slow" p14:dur="2000"/>
-    </mc:Choice>
-    <mc:Fallback>
-      <p:transition spd="slow"/>
-    </mc:Fallback>
-  </mc:AlternateContent>
+  <p:clrMapOvr>
+    <a:masterClrMapping/>
+  </p:clrMapOvr>
 </p:sld>
 </file>
 
 <file path=ppt/slides/slide7.xml><?xml version="1.0" encoding="utf-8"?>
-<p:sld xmlns:a="http://schemas.openxmlformats.org/drawingml/2006/main" xmlns:p="http://schemas.openxmlformats.org/presentationml/2006/main" xmlns:r="http://schemas.openxmlformats.org/officeDocument/2006/relationships" xmlns:p14="http://schemas.microsoft.com/office/powerpoint/2010/main" xmlns:p15="http://schemas.microsoft.com/office/powerpoint/2012/main" xmlns:mc="http://schemas.openxmlformats.org/markup-compatibility/2006">
+<p:sld xmlns:a="http://schemas.openxmlformats.org/drawingml/2006/main" xmlns:r="http://schemas.openxmlformats.org/officeDocument/2006/relationships" xmlns:p="http://schemas.openxmlformats.org/presentationml/2006/main">
   <p:cSld>
     <p:spTree>
       <p:nvGrpSpPr>
@@ -7439,6 +7961,7 @@
           <a:bodyPr anchor="ctr">
             <a:noAutofit/>
           </a:bodyPr>
+          <a:lstStyle/>
           <a:p>
             <a:pPr defTabSz="914400">
               <a:lnSpc>
@@ -7481,28 +8004,440 @@
         <p:spPr/>
         <p:txBody>
           <a:bodyPr/>
-          <a:p>
-            <a:r>
+          <a:lstStyle/>
+          <a:p>
+            <a:r>
+              <a:rPr dirty="0"/>
               <a:t>Causal Effect Estimation</a:t>
             </a:r>
+          </a:p>
+        </p:txBody>
+      </p:sp>
+      <p:sp>
+        <p:nvSpPr>
+          <p:cNvPr id="3" name="PlaceHolder 2">
+            <a:extLst>
+              <a:ext uri="{FF2B5EF4-FFF2-40B4-BE49-F238E27FC236}">
+                <a16:creationId xmlns:a16="http://schemas.microsoft.com/office/drawing/2014/main" id="{AC44EA8B-4A08-692D-8803-8DC57826F252}"/>
+              </a:ext>
+            </a:extLst>
+          </p:cNvPr>
+          <p:cNvSpPr txBox="1">
+            <a:spLocks/>
+          </p:cNvSpPr>
+          <p:nvPr/>
+        </p:nvSpPr>
+        <p:spPr>
+          <a:xfrm>
+            <a:off x="286560" y="1293480"/>
+            <a:ext cx="8694720" cy="3178800"/>
+          </a:xfrm>
+          <a:prstGeom prst="rect">
+            <a:avLst/>
+          </a:prstGeom>
+          <a:noFill/>
+          <a:ln w="0">
+            <a:noFill/>
+          </a:ln>
+        </p:spPr>
+        <p:txBody>
+          <a:bodyPr lIns="91440" tIns="45720" rIns="91440" bIns="45720" anchor="t">
+            <a:noAutofit/>
+          </a:bodyPr>
+          <a:lstStyle>
+            <a:lvl1pPr indent="0" algn="l" defTabSz="914400" rtl="0" eaLnBrk="1" latinLnBrk="0" hangingPunct="1">
+              <a:lnSpc>
+                <a:spcPct val="90000"/>
+              </a:lnSpc>
+              <a:spcBef>
+                <a:spcPct val="0"/>
+              </a:spcBef>
+              <a:buNone/>
+              <a:defRPr lang="sv-SE" sz="2600" b="1" u="none" strike="noStrike" kern="1200">
+                <a:solidFill>
+                  <a:srgbClr val="1E3A5F"/>
+                </a:solidFill>
+                <a:effectLst/>
+                <a:uFillTx/>
+                <a:latin typeface="Cambria"/>
+                <a:ea typeface="Cambria"/>
+                <a:cs typeface="+mj-cs"/>
+              </a:defRPr>
+            </a:lvl1pPr>
+          </a:lstStyle>
+          <a:p>
+            <a:pPr marL="228600" indent="-228600">
+              <a:spcBef>
+                <a:spcPts val="1001"/>
+              </a:spcBef>
+              <a:buClr>
+                <a:srgbClr val="000000"/>
+              </a:buClr>
+              <a:buFont typeface="Arial"/>
+              <a:buChar char="•"/>
+            </a:pPr>
+            <a:r>
+              <a:rPr lang="en-GB" sz="1800" dirty="0">
+                <a:solidFill>
+                  <a:schemeClr val="dk1"/>
+                </a:solidFill>
+                <a:latin typeface="Calibri"/>
+                <a:ea typeface="Calibri"/>
+              </a:rPr>
+              <a:t>Problem it solves: </a:t>
+            </a:r>
+            <a:r>
+              <a:rPr lang="en-GB" sz="1800" b="0" dirty="0">
+                <a:solidFill>
+                  <a:schemeClr val="dk1"/>
+                </a:solidFill>
+                <a:latin typeface="Calibri"/>
+                <a:ea typeface="Calibri"/>
+              </a:rPr>
+              <a:t>Given treated and untreated units that differ in their covariates (selection bias), how do I construct a comparable control group so that the outcome difference can be attributed to the treatment?</a:t>
+            </a:r>
+          </a:p>
+          <a:p>
+            <a:pPr marL="228600" indent="-228600">
+              <a:spcBef>
+                <a:spcPts val="1001"/>
+              </a:spcBef>
+              <a:buClr>
+                <a:srgbClr val="000000"/>
+              </a:buClr>
+              <a:buFont typeface="Arial"/>
+              <a:buChar char="•"/>
+            </a:pPr>
+            <a:r>
+              <a:rPr lang="en-GB" sz="1800" dirty="0">
+                <a:solidFill>
+                  <a:schemeClr val="dk1"/>
+                </a:solidFill>
+                <a:latin typeface="Calibri"/>
+                <a:ea typeface="Calibri"/>
+              </a:rPr>
+              <a:t>Key intuition: </a:t>
+            </a:r>
+            <a:r>
+              <a:rPr lang="en-GB" sz="1800" b="0" dirty="0">
+                <a:solidFill>
+                  <a:schemeClr val="dk1"/>
+                </a:solidFill>
+                <a:latin typeface="Calibri"/>
+                <a:ea typeface="Calibri"/>
+              </a:rPr>
+              <a:t>Instead of </a:t>
+            </a:r>
+            <a:r>
+              <a:rPr lang="en-GB" sz="1800" b="0" dirty="0" err="1">
+                <a:solidFill>
+                  <a:schemeClr val="dk1"/>
+                </a:solidFill>
+                <a:latin typeface="Calibri"/>
+                <a:ea typeface="Calibri"/>
+              </a:rPr>
+              <a:t>modeling</a:t>
+            </a:r>
+            <a:r>
+              <a:rPr lang="en-GB" sz="1800" b="0" dirty="0">
+                <a:solidFill>
+                  <a:schemeClr val="dk1"/>
+                </a:solidFill>
+                <a:latin typeface="Calibri"/>
+                <a:ea typeface="Calibri"/>
+              </a:rPr>
+              <a:t> the outcome directly, matching “restructures” the data: each treated unit is paired with a similar untreated unit. After matching, the two groups are balanced and we can simply compare outcomes.</a:t>
+            </a:r>
+          </a:p>
+          <a:p>
+            <a:pPr marL="228600" indent="-228600">
+              <a:spcBef>
+                <a:spcPts val="1001"/>
+              </a:spcBef>
+              <a:buClr>
+                <a:srgbClr val="000000"/>
+              </a:buClr>
+              <a:buFont typeface="Arial"/>
+              <a:buChar char="•"/>
+            </a:pPr>
+            <a:r>
+              <a:rPr lang="en-GB" sz="1800" dirty="0">
+                <a:solidFill>
+                  <a:schemeClr val="dk1"/>
+                </a:solidFill>
+                <a:latin typeface="Calibri"/>
+                <a:ea typeface="Calibri"/>
+              </a:rPr>
+              <a:t>Main limitations:</a:t>
+            </a:r>
+            <a:endParaRPr lang="en-GB" sz="1800" b="0" dirty="0">
+              <a:solidFill>
+                <a:schemeClr val="dk1"/>
+              </a:solidFill>
+              <a:latin typeface="Calibri"/>
+            </a:endParaRPr>
+          </a:p>
+          <a:p>
+            <a:pPr marL="685800" lvl="1" indent="-228600" algn="l">
+              <a:lnSpc>
+                <a:spcPct val="90000"/>
+              </a:lnSpc>
+              <a:spcBef>
+                <a:spcPts val="499"/>
+              </a:spcBef>
+              <a:buClr>
+                <a:srgbClr val="000000"/>
+              </a:buClr>
+              <a:buFont typeface="Arial"/>
+              <a:buChar char="•"/>
+            </a:pPr>
+            <a:r>
+              <a:rPr lang="en-GB" sz="1600" b="1" kern="0" dirty="0">
+                <a:solidFill>
+                  <a:schemeClr val="dk1"/>
+                </a:solidFill>
+                <a:latin typeface="Calibri"/>
+                <a:ea typeface="Calibri"/>
+              </a:rPr>
+              <a:t>Curse of dimensionality: </a:t>
+            </a:r>
+            <a:r>
+              <a:rPr lang="en-GB" sz="1600" kern="0" dirty="0">
+                <a:solidFill>
+                  <a:schemeClr val="dk1"/>
+                </a:solidFill>
+                <a:latin typeface="Calibri"/>
+                <a:ea typeface="Calibri"/>
+              </a:rPr>
+              <a:t>Exact matches become rare with many covariates</a:t>
+            </a:r>
+          </a:p>
+          <a:p>
+            <a:pPr marL="685800" lvl="1" indent="-228600" algn="l">
+              <a:lnSpc>
+                <a:spcPct val="90000"/>
+              </a:lnSpc>
+              <a:spcBef>
+                <a:spcPts val="499"/>
+              </a:spcBef>
+              <a:buClr>
+                <a:srgbClr val="000000"/>
+              </a:buClr>
+              <a:buFont typeface="Arial"/>
+              <a:buChar char="•"/>
+            </a:pPr>
+            <a:r>
+              <a:rPr lang="en-GB" sz="1600" b="1" kern="0" dirty="0">
+                <a:solidFill>
+                  <a:schemeClr val="dk1"/>
+                </a:solidFill>
+                <a:latin typeface="Calibri"/>
+                <a:ea typeface="Calibri"/>
+              </a:rPr>
+              <a:t>Model dependence</a:t>
+            </a:r>
+            <a:r>
+              <a:rPr lang="en-GB" sz="1600" kern="0" dirty="0">
+                <a:solidFill>
+                  <a:schemeClr val="dk1"/>
+                </a:solidFill>
+                <a:latin typeface="Calibri"/>
+                <a:ea typeface="Calibri"/>
+              </a:rPr>
+              <a:t>: quality depends on how well the matching is estimated (e.g., propensity score needs to be estimated)</a:t>
+            </a:r>
+          </a:p>
+          <a:p>
+            <a:pPr marL="685800" lvl="1" indent="-228600" algn="l">
+              <a:lnSpc>
+                <a:spcPct val="90000"/>
+              </a:lnSpc>
+              <a:spcBef>
+                <a:spcPts val="499"/>
+              </a:spcBef>
+              <a:buClr>
+                <a:srgbClr val="000000"/>
+              </a:buClr>
+              <a:buFont typeface="Arial"/>
+              <a:buChar char="•"/>
+            </a:pPr>
+            <a:r>
+              <a:rPr lang="en-GB" sz="1600" b="1" kern="0" dirty="0">
+                <a:solidFill>
+                  <a:schemeClr val="dk1"/>
+                </a:solidFill>
+                <a:latin typeface="Calibri"/>
+                <a:ea typeface="Calibri"/>
+              </a:rPr>
+              <a:t>Data loss: </a:t>
+            </a:r>
+            <a:r>
+              <a:rPr lang="en-GB" sz="1600" kern="0" dirty="0">
+                <a:solidFill>
+                  <a:schemeClr val="dk1"/>
+                </a:solidFill>
+                <a:latin typeface="Calibri"/>
+                <a:ea typeface="Calibri"/>
+              </a:rPr>
+              <a:t>Unmatched units are discarded → smaller effective sample</a:t>
+            </a:r>
+            <a:endParaRPr lang="en-GB" sz="1600" kern="0" dirty="0">
+              <a:solidFill>
+                <a:schemeClr val="dk1"/>
+              </a:solidFill>
+              <a:latin typeface="Calibri"/>
+            </a:endParaRPr>
+          </a:p>
+        </p:txBody>
+      </p:sp>
+      <p:sp>
+        <p:nvSpPr>
+          <p:cNvPr id="5" name="TextBox 1">
+            <a:extLst>
+              <a:ext uri="{FF2B5EF4-FFF2-40B4-BE49-F238E27FC236}">
+                <a16:creationId xmlns:a16="http://schemas.microsoft.com/office/drawing/2014/main" id="{77E15B34-B810-1D64-3927-DCCF349A3544}"/>
+              </a:ext>
+            </a:extLst>
+          </p:cNvPr>
+          <p:cNvSpPr txBox="1"/>
+          <p:nvPr/>
+        </p:nvSpPr>
+        <p:spPr>
+          <a:xfrm>
+            <a:off x="162720" y="4294980"/>
+            <a:ext cx="8447809" cy="506377"/>
+          </a:xfrm>
+          <a:prstGeom prst="rect">
+            <a:avLst/>
+          </a:prstGeom>
+          <a:noFill/>
+          <a:ln w="0">
+            <a:noFill/>
+          </a:ln>
+        </p:spPr>
+        <p:txBody>
+          <a:bodyPr wrap="square" lIns="90000" tIns="45000" rIns="90000" bIns="45000" anchor="t">
+            <a:spAutoFit/>
+          </a:bodyPr>
+          <a:lstStyle/>
+          <a:p>
+            <a:r>
+              <a:rPr lang="en-US" sz="900" b="0" u="none" strike="noStrike" dirty="0">
+                <a:solidFill>
+                  <a:srgbClr val="000000"/>
+                </a:solidFill>
+                <a:effectLst/>
+                <a:uFillTx/>
+                <a:latin typeface="Arial"/>
+              </a:rPr>
+              <a:t>Stuart, Elizabeth A. "Matching methods for causal inference: A review and a look forward." (2010)</a:t>
+            </a:r>
+            <a:r>
+              <a:rPr lang="en-US" sz="900" dirty="0">
+                <a:solidFill>
+                  <a:srgbClr val="000000"/>
+                </a:solidFill>
+                <a:latin typeface="Arial"/>
+              </a:rPr>
+              <a:t>.</a:t>
+            </a:r>
+            <a:br>
+              <a:rPr lang="en-US" sz="900" b="0" u="none" strike="noStrike" dirty="0">
+                <a:solidFill>
+                  <a:srgbClr val="000000"/>
+                </a:solidFill>
+                <a:effectLst/>
+                <a:uFillTx/>
+                <a:latin typeface="Arial"/>
+              </a:rPr>
+            </a:br>
+            <a:r>
+              <a:rPr lang="en-US" sz="900" b="0" u="none" strike="noStrike" dirty="0">
+                <a:solidFill>
+                  <a:srgbClr val="000000"/>
+                </a:solidFill>
+                <a:effectLst/>
+                <a:uFillTx/>
+                <a:latin typeface="Arial"/>
+              </a:rPr>
+              <a:t>Chapter 14 - Matching. “The Effect: An Introduction to Research Design and Causality”. Nick Huntington-Klein. CRC Press </a:t>
+            </a:r>
+            <a:r>
+              <a:rPr lang="en-US" sz="900" b="0" u="none" strike="noStrike" dirty="0">
+                <a:solidFill>
+                  <a:srgbClr val="000000"/>
+                </a:solidFill>
+                <a:effectLst/>
+                <a:uFillTx/>
+                <a:latin typeface="Arial"/>
+                <a:hlinkClick r:id="rId3"/>
+              </a:rPr>
+              <a:t>https://theeffectbook.net/index.html</a:t>
+            </a:r>
+            <a:r>
+              <a:rPr lang="en-US" sz="900" b="0" u="none" strike="noStrike" dirty="0">
+                <a:solidFill>
+                  <a:srgbClr val="000000"/>
+                </a:solidFill>
+                <a:effectLst/>
+                <a:uFillTx/>
+                <a:latin typeface="Arial"/>
+              </a:rPr>
+              <a:t> </a:t>
+            </a:r>
+            <a:br>
+              <a:rPr lang="en-US" sz="900" dirty="0">
+                <a:solidFill>
+                  <a:srgbClr val="000000"/>
+                </a:solidFill>
+              </a:rPr>
+            </a:br>
+            <a:r>
+              <a:rPr lang="en-US" sz="900" dirty="0">
+                <a:solidFill>
+                  <a:srgbClr val="000000"/>
+                </a:solidFill>
+              </a:rPr>
+              <a:t>6.4 - Propensity Scores and Inverse Probability Weighting (IPW). Introduction to Causal Inference. Brady Neals </a:t>
+            </a:r>
+            <a:r>
+              <a:rPr lang="en-US" sz="900" dirty="0">
+                <a:solidFill>
+                  <a:srgbClr val="000000"/>
+                </a:solidFill>
+                <a:hlinkClick r:id="rId4"/>
+              </a:rPr>
+              <a:t>https://youtu.be/YQDMlNIQSA8?si=1Gyzc5HFUkcAmLKv</a:t>
+            </a:r>
+            <a:r>
+              <a:rPr lang="en-US" sz="900" dirty="0">
+                <a:solidFill>
+                  <a:srgbClr val="000000"/>
+                </a:solidFill>
+              </a:rPr>
+              <a:t> </a:t>
+            </a:r>
+            <a:endParaRPr lang="en-US" sz="900" b="0" u="none" strike="noStrike" dirty="0">
+              <a:solidFill>
+                <a:srgbClr val="000000"/>
+              </a:solidFill>
+              <a:effectLst/>
+              <a:uFillTx/>
+              <a:latin typeface="Arial"/>
+            </a:endParaRPr>
           </a:p>
         </p:txBody>
       </p:sp>
     </p:spTree>
   </p:cSld>
-  <mc:AlternateContent>
-    <mc:Choice Requires="p14">
-      <p:transition spd="slow" p14:dur="2000"/>
-    </mc:Choice>
-    <mc:Fallback>
-      <p:transition spd="slow"/>
-    </mc:Fallback>
-  </mc:AlternateContent>
+  <p:clrMapOvr>
+    <a:masterClrMapping/>
+  </p:clrMapOvr>
 </p:sld>
 </file>
 
 <file path=ppt/slides/slide8.xml><?xml version="1.0" encoding="utf-8"?>
-<p:sld xmlns:a="http://schemas.openxmlformats.org/drawingml/2006/main" xmlns:p="http://schemas.openxmlformats.org/presentationml/2006/main" xmlns:r="http://schemas.openxmlformats.org/officeDocument/2006/relationships" xmlns:p14="http://schemas.microsoft.com/office/powerpoint/2010/main" xmlns:p15="http://schemas.microsoft.com/office/powerpoint/2012/main" xmlns:mc="http://schemas.openxmlformats.org/markup-compatibility/2006">
+<p:sld xmlns:a="http://schemas.openxmlformats.org/drawingml/2006/main" xmlns:r="http://schemas.openxmlformats.org/officeDocument/2006/relationships" xmlns:p="http://schemas.openxmlformats.org/presentationml/2006/main">
   <p:cSld>
     <p:spTree>
       <p:nvGrpSpPr>
@@ -7545,6 +8480,7 @@
           <a:bodyPr lIns="91440" tIns="45720" rIns="91440" bIns="45720" anchor="ctr">
             <a:noAutofit/>
           </a:bodyPr>
+          <a:lstStyle/>
           <a:p>
             <a:pPr indent="0" algn="l" defTabSz="914400">
               <a:lnSpc>
@@ -7602,6 +8538,7 @@
           <a:bodyPr lIns="91440" tIns="45720" rIns="91440" bIns="45720" anchor="t">
             <a:noAutofit/>
           </a:bodyPr>
+          <a:lstStyle/>
           <a:p>
             <a:pPr marL="228600" indent="-228600" algn="l" defTabSz="914400">
               <a:lnSpc>
@@ -7617,7 +8554,7 @@
               <a:buChar char="•"/>
             </a:pPr>
             <a:r>
-              <a:rPr lang="en-GB" sz="1800" b="1" u="none" strike="noStrike">
+              <a:rPr lang="en-GB" sz="1600" b="1" u="none" strike="noStrike" dirty="0">
                 <a:solidFill>
                   <a:schemeClr val="dk1"/>
                 </a:solidFill>
@@ -7629,7 +8566,7 @@
               <a:t>Problem it solves: </a:t>
             </a:r>
             <a:r>
-              <a:rPr lang="en-GB" sz="1800" b="0" u="none" strike="noStrike">
+              <a:rPr lang="en-GB" sz="1600" b="0" u="none" strike="noStrike" dirty="0">
                 <a:solidFill>
                   <a:schemeClr val="dk1"/>
                 </a:solidFill>
@@ -7640,7 +8577,7 @@
               </a:rPr>
               <a:t>How do I estimate treatment effects when the data is high-dimensional or the covariate–outcome relationship is complex and non-linear?</a:t>
             </a:r>
-            <a:endParaRPr lang="en-GB" sz="1800" b="0" u="none" strike="noStrike">
+            <a:endParaRPr lang="en-GB" sz="1600" b="0" u="none" strike="noStrike" dirty="0">
               <a:solidFill>
                 <a:schemeClr val="dk1"/>
               </a:solidFill>
@@ -7664,7 +8601,7 @@
               <a:buChar char="•"/>
             </a:pPr>
             <a:r>
-              <a:rPr lang="en-GB" sz="1800" b="1" u="none" strike="noStrike">
+              <a:rPr lang="en-GB" sz="1600" b="1" u="none" strike="noStrike" dirty="0">
                 <a:solidFill>
                   <a:schemeClr val="dk1"/>
                 </a:solidFill>
@@ -7676,7 +8613,7 @@
               <a:t>Key intuition: </a:t>
             </a:r>
             <a:r>
-              <a:rPr lang="en-GB" sz="1800" b="0" u="none" strike="noStrike">
+              <a:rPr lang="en-GB" sz="1600" b="0" u="none" strike="noStrike" dirty="0">
                 <a:solidFill>
                   <a:schemeClr val="dk1"/>
                 </a:solidFill>
@@ -7687,7 +8624,7 @@
               </a:rPr>
               <a:t>Use flexible ML models to learn how covariates relate to treatment and outcome (nuisance functions), then isolate the treatment effect. Combining the flexibility of ML with valid causal inference.</a:t>
             </a:r>
-            <a:endParaRPr lang="en-GB" sz="1800" b="0" u="none" strike="noStrike">
+            <a:endParaRPr lang="en-GB" sz="1600" b="0" u="none" strike="noStrike" dirty="0">
               <a:solidFill>
                 <a:schemeClr val="dk1"/>
               </a:solidFill>
@@ -7711,7 +8648,7 @@
               <a:buChar char="•"/>
             </a:pPr>
             <a:r>
-              <a:rPr lang="en-GB" sz="1800" b="1" u="none" strike="noStrike">
+              <a:rPr lang="en-GB" sz="1600" b="1" u="none" strike="noStrike" dirty="0">
                 <a:solidFill>
                   <a:schemeClr val="dk1"/>
                 </a:solidFill>
@@ -7723,7 +8660,7 @@
               <a:t>Families of techniques: </a:t>
             </a:r>
             <a:r>
-              <a:rPr lang="en-GB" sz="1800" b="0" u="none" strike="noStrike">
+              <a:rPr lang="en-GB" sz="1600" b="0" u="none" strike="noStrike" dirty="0">
                 <a:solidFill>
                   <a:schemeClr val="dk1"/>
                 </a:solidFill>
@@ -7734,7 +8671,7 @@
               </a:rPr>
               <a:t>Meta-Learners (S/T/X-Learner), Double ML, Causal Forests</a:t>
             </a:r>
-            <a:endParaRPr lang="en-GB" sz="1800" b="0" u="none" strike="noStrike">
+            <a:endParaRPr lang="en-GB" sz="1600" b="0" u="none" strike="noStrike" dirty="0">
               <a:solidFill>
                 <a:schemeClr val="dk1"/>
               </a:solidFill>
@@ -7758,7 +8695,7 @@
               <a:buChar char="•"/>
             </a:pPr>
             <a:r>
-              <a:rPr lang="en-GB" sz="1800" b="1" u="none" strike="noStrike">
+              <a:rPr lang="en-GB" sz="1600" b="1" u="none" strike="noStrike" dirty="0">
                 <a:solidFill>
                   <a:schemeClr val="dk1"/>
                 </a:solidFill>
@@ -7769,7 +8706,7 @@
               </a:rPr>
               <a:t>Double ML in 3 steps:</a:t>
             </a:r>
-            <a:endParaRPr lang="en-GB" sz="1800" b="0" u="none" strike="noStrike">
+            <a:endParaRPr lang="en-GB" sz="1600" b="0" u="none" strike="noStrike" dirty="0">
               <a:solidFill>
                 <a:schemeClr val="dk1"/>
               </a:solidFill>
@@ -7793,7 +8730,7 @@
               <a:buAutoNum type="arabicPeriod"/>
             </a:pPr>
             <a:r>
-              <a:rPr lang="en-GB" sz="1600" b="0" u="none" strike="noStrike">
+              <a:rPr lang="en-GB" sz="1400" b="0" u="none" strike="noStrike" dirty="0">
                 <a:solidFill>
                   <a:schemeClr val="dk1"/>
                 </a:solidFill>
@@ -7804,7 +8741,7 @@
               </a:rPr>
               <a:t>Predict T from X → residuals T~ (with a ML model)</a:t>
             </a:r>
-            <a:endParaRPr lang="en-GB" sz="1600" b="0" u="none" strike="noStrike">
+            <a:endParaRPr lang="en-GB" sz="1400" b="0" u="none" strike="noStrike" dirty="0">
               <a:solidFill>
                 <a:schemeClr val="dk1"/>
               </a:solidFill>
@@ -7828,7 +8765,7 @@
               <a:buAutoNum type="arabicPeriod"/>
             </a:pPr>
             <a:r>
-              <a:rPr lang="en-GB" sz="1600" b="0" u="none" strike="noStrike">
+              <a:rPr lang="en-GB" sz="1400" b="0" u="none" strike="noStrike" dirty="0">
                 <a:solidFill>
                   <a:schemeClr val="dk1"/>
                 </a:solidFill>
@@ -7839,7 +8776,7 @@
               </a:rPr>
               <a:t>Predict Y from X → residuals Y~ (with a ML model)</a:t>
             </a:r>
-            <a:endParaRPr lang="en-GB" sz="1600" b="0" u="none" strike="noStrike">
+            <a:endParaRPr lang="en-GB" sz="1400" b="0" u="none" strike="noStrike" dirty="0">
               <a:solidFill>
                 <a:schemeClr val="dk1"/>
               </a:solidFill>
@@ -7863,7 +8800,7 @@
               <a:buAutoNum type="arabicPeriod"/>
             </a:pPr>
             <a:r>
-              <a:rPr lang="en-GB" sz="1600" b="0" u="none" strike="noStrike">
+              <a:rPr lang="en-GB" sz="1400" b="0" u="none" strike="noStrike" dirty="0">
                 <a:solidFill>
                   <a:schemeClr val="dk1"/>
                 </a:solidFill>
@@ -7874,7 +8811,7 @@
               </a:rPr>
               <a:t>Regress Y~ on T~ → treatment effect (with a linear regression)</a:t>
             </a:r>
-            <a:endParaRPr lang="en-GB" sz="1600" b="0" u="none" strike="noStrike">
+            <a:endParaRPr lang="en-GB" sz="1400" b="0" u="none" strike="noStrike" dirty="0">
               <a:solidFill>
                 <a:schemeClr val="dk1"/>
               </a:solidFill>
@@ -7898,7 +8835,7 @@
               <a:buChar char="•"/>
             </a:pPr>
             <a:r>
-              <a:rPr lang="en-GB" sz="1800" b="1" u="none" strike="noStrike">
+              <a:rPr lang="en-GB" sz="1600" b="1" u="none" strike="noStrike" dirty="0">
                 <a:solidFill>
                   <a:schemeClr val="dk1"/>
                 </a:solidFill>
@@ -7910,7 +8847,7 @@
               <a:t>Main limitations:</a:t>
             </a:r>
             <a:r>
-              <a:rPr lang="en-GB" sz="1800" b="0" u="none" strike="noStrike">
+              <a:rPr lang="en-GB" sz="1600" b="0" u="none" strike="noStrike" dirty="0">
                 <a:solidFill>
                   <a:schemeClr val="dk1"/>
                 </a:solidFill>
@@ -7921,7 +8858,7 @@
               </a:rPr>
               <a:t> Needs larger samples than regression; requires cross-fitting.</a:t>
             </a:r>
-            <a:endParaRPr lang="en-GB" sz="1800" b="0" u="none" strike="noStrike">
+            <a:endParaRPr lang="en-GB" sz="1600" b="0" u="none" strike="noStrike" dirty="0">
               <a:solidFill>
                 <a:schemeClr val="dk1"/>
               </a:solidFill>
@@ -7993,7 +8930,7 @@
                 <a:latin typeface="Calibri"/>
                 <a:ea typeface="Calibri"/>
               </a:rPr>
-              <a:t>&lt;number&gt;</a:t>
+              <a:t>8</a:t>
             </a:fld>
             <a:endParaRPr lang="en-GB" sz="900" b="0" u="none" strike="noStrike">
               <a:solidFill>
@@ -8019,28 +8956,131 @@
         <p:spPr/>
         <p:txBody>
           <a:bodyPr/>
+          <a:lstStyle/>
           <a:p>
             <a:r>
               <a:t>Causal Effect Estimation</a:t>
             </a:r>
+          </a:p>
+        </p:txBody>
+      </p:sp>
+      <p:sp>
+        <p:nvSpPr>
+          <p:cNvPr id="3" name="TextBox 1">
+            <a:extLst>
+              <a:ext uri="{FF2B5EF4-FFF2-40B4-BE49-F238E27FC236}">
+                <a16:creationId xmlns:a16="http://schemas.microsoft.com/office/drawing/2014/main" id="{7708AA68-490A-9FAD-EA8C-F4129BC89F56}"/>
+              </a:ext>
+            </a:extLst>
+          </p:cNvPr>
+          <p:cNvSpPr txBox="1"/>
+          <p:nvPr/>
+        </p:nvSpPr>
+        <p:spPr>
+          <a:xfrm>
+            <a:off x="391320" y="4214576"/>
+            <a:ext cx="7090135" cy="552544"/>
+          </a:xfrm>
+          <a:prstGeom prst="rect">
+            <a:avLst/>
+          </a:prstGeom>
+          <a:noFill/>
+          <a:ln w="0">
+            <a:noFill/>
+          </a:ln>
+        </p:spPr>
+        <p:txBody>
+          <a:bodyPr wrap="square" lIns="90000" tIns="45000" rIns="90000" bIns="45000" anchor="t">
+            <a:spAutoFit/>
+          </a:bodyPr>
+          <a:lstStyle/>
+          <a:p>
+            <a:br>
+              <a:rPr lang="en-US" sz="1000" dirty="0">
+                <a:solidFill>
+                  <a:srgbClr val="000000"/>
+                </a:solidFill>
+              </a:rPr>
+            </a:br>
+            <a:r>
+              <a:rPr lang="en-US" sz="1000" dirty="0">
+                <a:solidFill>
+                  <a:srgbClr val="000000"/>
+                </a:solidFill>
+              </a:rPr>
+              <a:t>Chapter 6. Introduction to Causal Inference. Brady Neals. </a:t>
+            </a:r>
+            <a:r>
+              <a:rPr lang="en-US" sz="1000" dirty="0">
+                <a:solidFill>
+                  <a:srgbClr val="000000"/>
+                </a:solidFill>
+                <a:hlinkClick r:id="rId2"/>
+              </a:rPr>
+              <a:t>https://www.bradyneal.com/slides/6%20-%20Estimation.pdf</a:t>
+            </a:r>
+            <a:br>
+              <a:rPr lang="en-US" sz="1000" dirty="0">
+                <a:solidFill>
+                  <a:srgbClr val="000000"/>
+                </a:solidFill>
+              </a:rPr>
+            </a:br>
+            <a:r>
+              <a:rPr lang="en-US" sz="1000" dirty="0" err="1">
+                <a:solidFill>
+                  <a:srgbClr val="000000"/>
+                </a:solidFill>
+              </a:rPr>
+              <a:t>EconML</a:t>
+            </a:r>
+            <a:r>
+              <a:rPr lang="en-US" sz="1000" dirty="0">
+                <a:solidFill>
+                  <a:srgbClr val="000000"/>
+                </a:solidFill>
+              </a:rPr>
+              <a:t> </a:t>
+            </a:r>
+            <a:r>
+              <a:rPr lang="de-DE" sz="1000" dirty="0">
+                <a:hlinkClick r:id="rId3"/>
+              </a:rPr>
+              <a:t>https://www.pywhy.org/EconML/spec/estimation.html</a:t>
+            </a:r>
+            <a:r>
+              <a:rPr lang="de-DE" sz="1000" dirty="0"/>
+              <a:t> </a:t>
+            </a:r>
+            <a:r>
+              <a:rPr lang="en-US" sz="1000" dirty="0">
+                <a:solidFill>
+                  <a:srgbClr val="000000"/>
+                </a:solidFill>
+              </a:rPr>
+              <a:t>  </a:t>
+            </a:r>
+            <a:endParaRPr lang="en-US" sz="1000" b="0" u="none" strike="noStrike" dirty="0">
+              <a:solidFill>
+                <a:srgbClr val="000000"/>
+              </a:solidFill>
+              <a:effectLst/>
+              <a:uFillTx/>
+              <a:latin typeface="Arial"/>
+            </a:endParaRPr>
           </a:p>
         </p:txBody>
       </p:sp>
     </p:spTree>
   </p:cSld>
-  <mc:AlternateContent>
-    <mc:Choice Requires="p14">
-      <p:transition spd="slow" p14:dur="2000"/>
-    </mc:Choice>
-    <mc:Fallback>
-      <p:transition spd="slow"/>
-    </mc:Fallback>
-  </mc:AlternateContent>
+  <p:clrMapOvr>
+    <a:masterClrMapping/>
+  </p:clrMapOvr>
 </p:sld>
 </file>
 
 <file path=ppt/slides/slide9.xml><?xml version="1.0" encoding="utf-8"?>
-<p:sld xmlns:a="http://schemas.openxmlformats.org/drawingml/2006/main" xmlns:p="http://schemas.openxmlformats.org/presentationml/2006/main" xmlns:r="http://schemas.openxmlformats.org/officeDocument/2006/relationships" xmlns:p14="http://schemas.microsoft.com/office/powerpoint/2010/main" xmlns:p15="http://schemas.microsoft.com/office/powerpoint/2012/main" xmlns:mc="http://schemas.openxmlformats.org/markup-compatibility/2006">
+<p:sld xmlns:a="http://schemas.openxmlformats.org/drawingml/2006/main" xmlns:r="http://schemas.openxmlformats.org/officeDocument/2006/relationships" xmlns:p="http://schemas.openxmlformats.org/presentationml/2006/main">
   <p:cSld>
     <p:spTree>
       <p:nvGrpSpPr>
@@ -8161,6 +9201,7 @@
           <a:bodyPr lIns="91440" tIns="45720" rIns="91440" bIns="45720" anchor="ctr">
             <a:noAutofit/>
           </a:bodyPr>
+          <a:lstStyle/>
           <a:p>
             <a:pPr indent="0" algn="l" defTabSz="914400">
               <a:lnSpc>
@@ -8252,7 +9293,7 @@
                 <a:latin typeface="Calibri"/>
                 <a:ea typeface="Calibri"/>
               </a:rPr>
-              <a:t>&lt;number&gt;</a:t>
+              <a:t>9</a:t>
             </a:fld>
             <a:endParaRPr lang="en-GB" sz="900" b="0" u="none" strike="noStrike">
               <a:solidFill>
@@ -8265,21 +9306,282 @@
           </a:p>
         </p:txBody>
       </p:sp>
+      <p:sp>
+        <p:nvSpPr>
+          <p:cNvPr id="2" name="PlaceHolder 2">
+            <a:extLst>
+              <a:ext uri="{FF2B5EF4-FFF2-40B4-BE49-F238E27FC236}">
+                <a16:creationId xmlns:a16="http://schemas.microsoft.com/office/drawing/2014/main" id="{26433B7E-5246-F688-2852-B1C1E4E52149}"/>
+              </a:ext>
+            </a:extLst>
+          </p:cNvPr>
+          <p:cNvSpPr txBox="1">
+            <a:spLocks/>
+          </p:cNvSpPr>
+          <p:nvPr/>
+        </p:nvSpPr>
+        <p:spPr>
+          <a:xfrm>
+            <a:off x="286560" y="1293480"/>
+            <a:ext cx="8694720" cy="3178800"/>
+          </a:xfrm>
+          <a:prstGeom prst="rect">
+            <a:avLst/>
+          </a:prstGeom>
+          <a:noFill/>
+          <a:ln w="0">
+            <a:noFill/>
+          </a:ln>
+        </p:spPr>
+        <p:txBody>
+          <a:bodyPr lIns="91440" tIns="45720" rIns="91440" bIns="45720" anchor="t">
+            <a:noAutofit/>
+          </a:bodyPr>
+          <a:lstStyle>
+            <a:lvl1pPr indent="0" algn="l" defTabSz="914400" rtl="0" eaLnBrk="1" latinLnBrk="0" hangingPunct="1">
+              <a:lnSpc>
+                <a:spcPct val="90000"/>
+              </a:lnSpc>
+              <a:spcBef>
+                <a:spcPct val="0"/>
+              </a:spcBef>
+              <a:buNone/>
+              <a:defRPr lang="sv-SE" sz="2600" b="1" u="none" strike="noStrike" kern="1200">
+                <a:solidFill>
+                  <a:srgbClr val="1E3A5F"/>
+                </a:solidFill>
+                <a:effectLst/>
+                <a:uFillTx/>
+                <a:latin typeface="Cambria"/>
+                <a:ea typeface="Cambria"/>
+                <a:cs typeface="+mj-cs"/>
+              </a:defRPr>
+            </a:lvl1pPr>
+          </a:lstStyle>
+          <a:p>
+            <a:pPr marL="228600" indent="-228600">
+              <a:spcBef>
+                <a:spcPts val="1001"/>
+              </a:spcBef>
+              <a:buClr>
+                <a:srgbClr val="000000"/>
+              </a:buClr>
+              <a:buFont typeface="Arial"/>
+              <a:buChar char="•"/>
+            </a:pPr>
+            <a:r>
+              <a:rPr lang="en-GB" sz="1800" dirty="0" err="1">
+                <a:solidFill>
+                  <a:schemeClr val="dk1"/>
+                </a:solidFill>
+                <a:latin typeface="Calibri"/>
+                <a:ea typeface="Calibri"/>
+              </a:rPr>
+              <a:t>EconML</a:t>
+            </a:r>
+            <a:r>
+              <a:rPr lang="en-GB" sz="1800" dirty="0">
+                <a:solidFill>
+                  <a:schemeClr val="dk1"/>
+                </a:solidFill>
+                <a:latin typeface="Calibri"/>
+                <a:ea typeface="Calibri"/>
+              </a:rPr>
+              <a:t> (python) </a:t>
+            </a:r>
+            <a:r>
+              <a:rPr lang="en-GB" sz="1800" dirty="0">
+                <a:solidFill>
+                  <a:schemeClr val="dk1"/>
+                </a:solidFill>
+                <a:latin typeface="Calibri"/>
+                <a:ea typeface="Calibri"/>
+                <a:hlinkClick r:id="rId2"/>
+              </a:rPr>
+              <a:t>https://www.pywhy.org/EconML/index.html</a:t>
+            </a:r>
+            <a:r>
+              <a:rPr lang="en-GB" sz="1800" dirty="0">
+                <a:solidFill>
+                  <a:schemeClr val="dk1"/>
+                </a:solidFill>
+                <a:latin typeface="Calibri"/>
+                <a:ea typeface="Calibri"/>
+              </a:rPr>
+              <a:t> </a:t>
+            </a:r>
+          </a:p>
+          <a:p>
+            <a:pPr marL="228600" indent="-228600">
+              <a:spcBef>
+                <a:spcPts val="1001"/>
+              </a:spcBef>
+              <a:buClr>
+                <a:srgbClr val="000000"/>
+              </a:buClr>
+              <a:buFont typeface="Arial"/>
+              <a:buChar char="•"/>
+            </a:pPr>
+            <a:r>
+              <a:rPr lang="en-GB" sz="1800" dirty="0" err="1">
+                <a:solidFill>
+                  <a:schemeClr val="dk1"/>
+                </a:solidFill>
+                <a:latin typeface="Calibri"/>
+                <a:ea typeface="Calibri"/>
+              </a:rPr>
+              <a:t>DoubleML</a:t>
+            </a:r>
+            <a:r>
+              <a:rPr lang="en-GB" sz="1800" dirty="0">
+                <a:solidFill>
+                  <a:schemeClr val="dk1"/>
+                </a:solidFill>
+                <a:latin typeface="Calibri"/>
+                <a:ea typeface="Calibri"/>
+              </a:rPr>
+              <a:t> (python/R) </a:t>
+            </a:r>
+            <a:r>
+              <a:rPr lang="en-GB" sz="1800" dirty="0">
+                <a:solidFill>
+                  <a:schemeClr val="dk1"/>
+                </a:solidFill>
+                <a:latin typeface="Calibri"/>
+                <a:ea typeface="Calibri"/>
+                <a:hlinkClick r:id="rId3"/>
+              </a:rPr>
+              <a:t>https://docs.doubleml.org/stable/index.html</a:t>
+            </a:r>
+            <a:r>
+              <a:rPr lang="en-GB" sz="1800" dirty="0">
+                <a:solidFill>
+                  <a:schemeClr val="dk1"/>
+                </a:solidFill>
+                <a:latin typeface="Calibri"/>
+                <a:ea typeface="Calibri"/>
+              </a:rPr>
+              <a:t> </a:t>
+            </a:r>
+          </a:p>
+          <a:p>
+            <a:pPr marL="228600" indent="-228600">
+              <a:spcBef>
+                <a:spcPts val="1001"/>
+              </a:spcBef>
+              <a:buClr>
+                <a:srgbClr val="000000"/>
+              </a:buClr>
+              <a:buFont typeface="Arial"/>
+              <a:buChar char="•"/>
+            </a:pPr>
+            <a:r>
+              <a:rPr lang="en-GB" sz="1800" dirty="0" err="1">
+                <a:solidFill>
+                  <a:schemeClr val="dk1"/>
+                </a:solidFill>
+                <a:latin typeface="Calibri"/>
+                <a:ea typeface="Calibri"/>
+              </a:rPr>
+              <a:t>CausalML</a:t>
+            </a:r>
+            <a:r>
+              <a:rPr lang="en-GB" sz="1800" dirty="0">
+                <a:solidFill>
+                  <a:schemeClr val="dk1"/>
+                </a:solidFill>
+                <a:latin typeface="Calibri"/>
+                <a:ea typeface="Calibri"/>
+              </a:rPr>
+              <a:t> (python) https://causalml.readthedocs.io/en/latest/about.html  </a:t>
+            </a:r>
+          </a:p>
+          <a:p>
+            <a:pPr marL="228600" indent="-228600">
+              <a:spcBef>
+                <a:spcPts val="1001"/>
+              </a:spcBef>
+              <a:buClr>
+                <a:srgbClr val="000000"/>
+              </a:buClr>
+              <a:buFont typeface="Arial"/>
+              <a:buChar char="•"/>
+            </a:pPr>
+            <a:r>
+              <a:rPr lang="en-GB" sz="1800" dirty="0" err="1">
+                <a:solidFill>
+                  <a:schemeClr val="dk1"/>
+                </a:solidFill>
+                <a:latin typeface="Calibri"/>
+                <a:ea typeface="Calibri"/>
+              </a:rPr>
+              <a:t>Matchit</a:t>
+            </a:r>
+            <a:r>
+              <a:rPr lang="en-GB" sz="1800" dirty="0">
+                <a:solidFill>
+                  <a:schemeClr val="dk1"/>
+                </a:solidFill>
+                <a:latin typeface="Calibri"/>
+                <a:ea typeface="Calibri"/>
+              </a:rPr>
+              <a:t> (R) </a:t>
+            </a:r>
+            <a:r>
+              <a:rPr lang="en-GB" sz="1800" dirty="0">
+                <a:solidFill>
+                  <a:schemeClr val="dk1"/>
+                </a:solidFill>
+                <a:latin typeface="Calibri"/>
+                <a:ea typeface="Calibri"/>
+                <a:hlinkClick r:id="rId4"/>
+              </a:rPr>
+              <a:t>https://cran.r-project.org/web/packages/MatchIt/vignettes/MatchIt.html</a:t>
+            </a:r>
+            <a:r>
+              <a:rPr lang="en-GB" sz="1800" dirty="0">
+                <a:solidFill>
+                  <a:schemeClr val="dk1"/>
+                </a:solidFill>
+                <a:latin typeface="Calibri"/>
+                <a:ea typeface="Calibri"/>
+              </a:rPr>
+              <a:t>  (Python: </a:t>
+            </a:r>
+            <a:r>
+              <a:rPr lang="en-GB" sz="1800" dirty="0">
+                <a:solidFill>
+                  <a:schemeClr val="dk1"/>
+                </a:solidFill>
+                <a:latin typeface="Calibri"/>
+                <a:ea typeface="Calibri"/>
+                <a:hlinkClick r:id="rId5"/>
+              </a:rPr>
+              <a:t>https://github.com/jtuenner/pymatchit</a:t>
+            </a:r>
+            <a:r>
+              <a:rPr lang="en-GB" sz="1800" dirty="0">
+                <a:solidFill>
+                  <a:schemeClr val="dk1"/>
+                </a:solidFill>
+                <a:latin typeface="Calibri"/>
+                <a:ea typeface="Calibri"/>
+              </a:rPr>
+              <a:t> )</a:t>
+            </a:r>
+          </a:p>
+        </p:txBody>
+      </p:sp>
     </p:spTree>
   </p:cSld>
-  <mc:AlternateContent>
-    <mc:Choice Requires="p14">
-      <p:transition spd="slow" p14:dur="2000"/>
-    </mc:Choice>
-    <mc:Fallback>
-      <p:transition spd="slow"/>
-    </mc:Fallback>
-  </mc:AlternateContent>
+  <p:clrMapOvr>
+    <a:masterClrMapping/>
+  </p:clrMapOvr>
 </p:sld>
 </file>
 
 <file path=ppt/theme/theme1.xml><?xml version="1.0" encoding="utf-8"?>
-<a:theme xmlns:a="http://schemas.openxmlformats.org/drawingml/2006/main" xmlns:r="http://schemas.openxmlformats.org/officeDocument/2006/relationships" name="Anpassad formgivning">
+<a:theme xmlns:a="http://schemas.openxmlformats.org/drawingml/2006/main" name="Anpassad formgivning">
   <a:themeElements>
     <a:clrScheme name="Office">
       <a:dk1>
@@ -8321,12 +9623,12 @@
     </a:clrScheme>
     <a:fontScheme name="Office">
       <a:majorFont>
-        <a:latin typeface="Aptos Display" panose="02110004020202020204" pitchFamily="0" charset="1"/>
+        <a:latin typeface="Aptos Display" panose="02110004020202020204"/>
         <a:ea typeface=""/>
         <a:cs typeface=""/>
       </a:majorFont>
       <a:minorFont>
-        <a:latin typeface="Aptos" panose="02110004020202020204" pitchFamily="0" charset="1"/>
+        <a:latin typeface="Aptos" panose="02110004020202020204"/>
         <a:ea typeface=""/>
         <a:cs typeface=""/>
       </a:minorFont>
@@ -8358,7 +9660,7 @@
             </a:gs>
           </a:gsLst>
           <a:lin ang="5400000" scaled="0"/>
-          <a:tileRect l="0" t="0" r="0" b="0"/>
+          <a:tileRect/>
         </a:gradFill>
         <a:gradFill>
           <a:gsLst>
@@ -8382,7 +9684,7 @@
             </a:gs>
           </a:gsLst>
           <a:lin ang="5400000" scaled="0"/>
-          <a:tileRect l="0" t="0" r="0" b="0"/>
+          <a:tileRect/>
         </a:gradFill>
       </a:fillStyleLst>
       <a:lnStyleLst>
@@ -8442,16 +9744,18 @@
             </a:gs>
           </a:gsLst>
           <a:lin ang="5400000" scaled="0"/>
-          <a:tileRect l="0" t="0" r="0" b="0"/>
+          <a:tileRect/>
         </a:gradFill>
       </a:bgFillStyleLst>
     </a:fmtScheme>
   </a:themeElements>
+  <a:objectDefaults/>
+  <a:extraClrSchemeLst/>
 </a:theme>
 </file>
 
-<file path=ppt/theme/theme6.xml><?xml version="1.0" encoding="utf-8"?>
-<a:theme xmlns:a="http://schemas.openxmlformats.org/drawingml/2006/main" xmlns:r="http://schemas.openxmlformats.org/officeDocument/2006/relationships" name="Office Theme">
+<file path=ppt/theme/theme2.xml><?xml version="1.0" encoding="utf-8"?>
+<a:theme xmlns:a="http://schemas.openxmlformats.org/drawingml/2006/main" name="Office Theme">
   <a:themeElements>
     <a:clrScheme name="LibreOffice">
       <a:dk1>
@@ -8493,14 +9797,14 @@
     </a:clrScheme>
     <a:fontScheme name="Office">
       <a:majorFont>
-        <a:latin typeface="Arial" pitchFamily="0" charset="1"/>
-        <a:ea typeface="DejaVu Sans" pitchFamily="0" charset="1"/>
-        <a:cs typeface="DejaVu Sans" pitchFamily="0" charset="1"/>
+        <a:latin typeface="Arial"/>
+        <a:ea typeface="DejaVu Sans"/>
+        <a:cs typeface="DejaVu Sans"/>
       </a:majorFont>
       <a:minorFont>
-        <a:latin typeface="Arial" pitchFamily="0" charset="1"/>
-        <a:ea typeface="DejaVu Sans" pitchFamily="0" charset="1"/>
-        <a:cs typeface="DejaVu Sans" pitchFamily="0" charset="1"/>
+        <a:latin typeface="Arial"/>
+        <a:ea typeface="DejaVu Sans"/>
+        <a:cs typeface="DejaVu Sans"/>
       </a:minorFont>
     </a:fontScheme>
     <a:fmtScheme>
@@ -8553,5 +9857,7 @@
       </a:bgFillStyleLst>
     </a:fmtScheme>
   </a:themeElements>
+  <a:objectDefaults/>
+  <a:extraClrSchemeLst/>
 </a:theme>
 </file>
</xml_diff>